<commit_message>
Fix corrupted pptx: drop stale co-authoring parts
PowerPointでファイルが開けない問題を修正。テンプレートから引き継いだ
共同編集・変更履歴パーツ（changesInfos／revisionInfo／authors）が削除済み
スライドを参照したままとなり、破損ファイルと判定されていた。

スライド削除を python-pptx の関係グラフ経由に変更し、到達不能となった
パーツを確実に除外。あわせて上記の共同編集パーツを削除。内容・デザインは
変更なし（2枚）。

Co-Authored-By: Claude Opus 4.8 <noreply@anthropic.com>
Claude-Session: https://claude.ai/code/session_01JPzR9PgdjEvTujeJxwKNpL
</commit_message>
<xml_diff>
--- a/docs/コパイロットスタジオ_事前相談会②_会議資料.pptx
+++ b/docs/コパイロットスタジオ_事前相談会②_会議資料.pptx
@@ -224,266 +224,6 @@
     </p:ext>
   </p:extLst>
 </p:presentation>
-</file>
-
-<file path=ppt/authors.xml><?xml version="1.0" encoding="utf-8"?>
-<p188:authorLst xmlns:a="http://schemas.openxmlformats.org/drawingml/2006/main" xmlns:r="http://schemas.openxmlformats.org/officeDocument/2006/relationships" xmlns:p188="http://schemas.microsoft.com/office/powerpoint/2018/8/main">
-  <p188:author id="{B93B4266-0FF5-64F0-FA58-A1F23455564B}" name="久保田郁哉" initials="久保田郁哉" userId="久保田郁哉" providerId="None"/>
-  <p188:author id="{AC273978-33BA-87E9-9480-1FB84D67A3AD}" name="morita akiko" initials="ma" userId="S::morita.akiko@lowcode.co.jp::90408e21-7a02-4982-95a6-6840885cf3c6" providerId="AD"/>
-  <p188:author id="{693EB579-ACED-138A-227B-18475408DB58}" name="suekane risa" initials="sr" userId="S::suekane.risa@lowcode.co.jp::6671a883-47e3-4867-b7b0-f7d2778060b3" providerId="AD"/>
-  <p188:author id="{1ACAB0C1-B804-A4F7-FCCE-6DE1D8EF8214}" name="katayama sho" initials="sk" userId="S::katayama.sho@lowcode.co.jp::49ea1565-1ae6-4500-a7e8-783af7c77e30" providerId="AD"/>
-  <p188:author id="{AF25C1DD-6706-C995-6EE9-0E9A01E29D77}" name="aoki koichi" initials="晃青" userId="S::aoki.koichi@lowcode.co.jp::00b14e93-8605-4462-b61b-52d4818a892a" providerId="AD"/>
-  <p188:author id="{B18043FF-2C97-01B7-4E1D-147ADA62DAAE}" name="shibata mari" initials="ms" userId="S::shibata.mari@lowcode.co.jp::3f1d3d7e-bb9c-4d8e-a4ec-49da71ed2c5f" providerId="AD"/>
-</p188:authorLst>
-</file>
-
-<file path=ppt/revisionInfo.xml><?xml version="1.0" encoding="utf-8"?>
-<p1510:revInfo xmlns:a="http://schemas.openxmlformats.org/drawingml/2006/main" xmlns:r="http://schemas.openxmlformats.org/officeDocument/2006/relationships" xmlns:p1510="http://schemas.microsoft.com/office/powerpoint/2015/10/main">
-  <p1510:revLst>
-    <p1510:client id="{B25FB36F-E0EA-7BCA-5154-982983B7251B}" v="1" dt="2026-07-16T04:13:22.965"/>
-  </p1510:revLst>
-</p1510:revInfo>
-</file>
-
-<file path=ppt/changesInfos/changesInfo1.xml><?xml version="1.0" encoding="utf-8"?>
-<pc:chgInfo xmlns:a="http://schemas.openxmlformats.org/drawingml/2006/main" xmlns:r="http://schemas.openxmlformats.org/officeDocument/2006/relationships" xmlns:ac="http://schemas.microsoft.com/office/drawing/2013/main/command" xmlns:pc="http://schemas.microsoft.com/office/powerpoint/2013/main/command">
-  <pc:docChgLst>
-    <pc:chgData name="伊東 千尋" userId="S::cito_cardnet.co.jp#ext#@lowcodecojp.onmicrosoft.com::35527b19-bb60-4cbd-88f7-e76b000149f9" providerId="AD" clId="Web-{57454AF4-2F33-0E2D-9E96-DB343DC314AF}"/>
-    <pc:docChg chg="modSld sldOrd">
-      <pc:chgData name="伊東 千尋" userId="S::cito_cardnet.co.jp#ext#@lowcodecojp.onmicrosoft.com::35527b19-bb60-4cbd-88f7-e76b000149f9" providerId="AD" clId="Web-{57454AF4-2F33-0E2D-9E96-DB343DC314AF}" dt="2026-07-09T10:58:32.053" v="3"/>
-      <pc:docMkLst>
-        <pc:docMk/>
-      </pc:docMkLst>
-      <pc:sldChg chg="modSp">
-        <pc:chgData name="伊東 千尋" userId="S::cito_cardnet.co.jp#ext#@lowcodecojp.onmicrosoft.com::35527b19-bb60-4cbd-88f7-e76b000149f9" providerId="AD" clId="Web-{57454AF4-2F33-0E2D-9E96-DB343DC314AF}" dt="2026-07-09T10:52:43.181" v="1" actId="1076"/>
-        <pc:sldMkLst>
-          <pc:docMk/>
-          <pc:sldMk cId="4195799110" sldId="273"/>
-        </pc:sldMkLst>
-        <pc:spChg chg="mod">
-          <ac:chgData name="伊東 千尋" userId="S::cito_cardnet.co.jp#ext#@lowcodecojp.onmicrosoft.com::35527b19-bb60-4cbd-88f7-e76b000149f9" providerId="AD" clId="Web-{57454AF4-2F33-0E2D-9E96-DB343DC314AF}" dt="2026-07-09T10:52:43.181" v="1" actId="1076"/>
-          <ac:spMkLst>
-            <pc:docMk/>
-            <pc:sldMk cId="4195799110" sldId="273"/>
-            <ac:spMk id="29" creationId="{C9152791-F537-EAA5-4460-63024FAA0B8F}"/>
-          </ac:spMkLst>
-        </pc:spChg>
-      </pc:sldChg>
-      <pc:sldChg chg="ord">
-        <pc:chgData name="伊東 千尋" userId="S::cito_cardnet.co.jp#ext#@lowcodecojp.onmicrosoft.com::35527b19-bb60-4cbd-88f7-e76b000149f9" providerId="AD" clId="Web-{57454AF4-2F33-0E2D-9E96-DB343DC314AF}" dt="2026-07-09T10:54:40.170" v="2"/>
-        <pc:sldMkLst>
-          <pc:docMk/>
-          <pc:sldMk cId="281921604" sldId="275"/>
-        </pc:sldMkLst>
-      </pc:sldChg>
-      <pc:sldChg chg="ord">
-        <pc:chgData name="伊東 千尋" userId="S::cito_cardnet.co.jp#ext#@lowcodecojp.onmicrosoft.com::35527b19-bb60-4cbd-88f7-e76b000149f9" providerId="AD" clId="Web-{57454AF4-2F33-0E2D-9E96-DB343DC314AF}" dt="2026-07-09T10:58:32.053" v="3"/>
-        <pc:sldMkLst>
-          <pc:docMk/>
-          <pc:sldMk cId="4247146017" sldId="2147483644"/>
-        </pc:sldMkLst>
-      </pc:sldChg>
-    </pc:docChg>
-  </pc:docChgLst>
-  <pc:docChgLst>
-    <pc:chgData name="nakamura takuya" userId="727bb4a0-377a-4a8e-a89d-8efa14875c2f" providerId="ADAL" clId="{7D6FC31F-3357-4373-B706-004F3C0B89A4}"/>
-    <pc:docChg chg="delSld modSld modSection">
-      <pc:chgData name="nakamura takuya" userId="727bb4a0-377a-4a8e-a89d-8efa14875c2f" providerId="ADAL" clId="{7D6FC31F-3357-4373-B706-004F3C0B89A4}" dt="2026-07-08T07:35:41.779" v="188" actId="14100"/>
-      <pc:docMkLst>
-        <pc:docMk/>
-      </pc:docMkLst>
-      <pc:sldChg chg="modSp mod">
-        <pc:chgData name="nakamura takuya" userId="727bb4a0-377a-4a8e-a89d-8efa14875c2f" providerId="ADAL" clId="{7D6FC31F-3357-4373-B706-004F3C0B89A4}" dt="2026-07-08T07:27:29.975" v="75" actId="20577"/>
-        <pc:sldMkLst>
-          <pc:docMk/>
-          <pc:sldMk cId="3978759848" sldId="257"/>
-        </pc:sldMkLst>
-        <pc:spChg chg="mod">
-          <ac:chgData name="nakamura takuya" userId="727bb4a0-377a-4a8e-a89d-8efa14875c2f" providerId="ADAL" clId="{7D6FC31F-3357-4373-B706-004F3C0B89A4}" dt="2026-07-08T07:27:29.975" v="75" actId="20577"/>
-          <ac:spMkLst>
-            <pc:docMk/>
-            <pc:sldMk cId="3978759848" sldId="257"/>
-            <ac:spMk id="5" creationId="{FBB79653-B9F1-A0CE-21A2-837D8F6A770F}"/>
-          </ac:spMkLst>
-        </pc:spChg>
-      </pc:sldChg>
-      <pc:sldChg chg="modSp mod">
-        <pc:chgData name="nakamura takuya" userId="727bb4a0-377a-4a8e-a89d-8efa14875c2f" providerId="ADAL" clId="{7D6FC31F-3357-4373-B706-004F3C0B89A4}" dt="2026-07-08T07:28:05.473" v="91" actId="14100"/>
-        <pc:sldMkLst>
-          <pc:docMk/>
-          <pc:sldMk cId="1889299086" sldId="284"/>
-        </pc:sldMkLst>
-        <pc:spChg chg="mod">
-          <ac:chgData name="nakamura takuya" userId="727bb4a0-377a-4a8e-a89d-8efa14875c2f" providerId="ADAL" clId="{7D6FC31F-3357-4373-B706-004F3C0B89A4}" dt="2026-07-08T07:28:05.473" v="91" actId="14100"/>
-          <ac:spMkLst>
-            <pc:docMk/>
-            <pc:sldMk cId="1889299086" sldId="284"/>
-            <ac:spMk id="5" creationId="{5BC15884-7C38-082E-DCF6-00EC18E6E719}"/>
-          </ac:spMkLst>
-        </pc:spChg>
-      </pc:sldChg>
-      <pc:sldChg chg="addSp mod">
-        <pc:chgData name="nakamura takuya" userId="727bb4a0-377a-4a8e-a89d-8efa14875c2f" providerId="ADAL" clId="{7D6FC31F-3357-4373-B706-004F3C0B89A4}" dt="2026-07-08T07:29:10.467" v="157" actId="22"/>
-        <pc:sldMkLst>
-          <pc:docMk/>
-          <pc:sldMk cId="828979641" sldId="285"/>
-        </pc:sldMkLst>
-        <pc:spChg chg="add">
-          <ac:chgData name="nakamura takuya" userId="727bb4a0-377a-4a8e-a89d-8efa14875c2f" providerId="ADAL" clId="{7D6FC31F-3357-4373-B706-004F3C0B89A4}" dt="2026-07-08T07:29:10.467" v="157" actId="22"/>
-          <ac:spMkLst>
-            <pc:docMk/>
-            <pc:sldMk cId="828979641" sldId="285"/>
-            <ac:spMk id="12" creationId="{F7F0C924-CE0C-4E1D-DDE1-C03E0EFE4232}"/>
-          </ac:spMkLst>
-        </pc:spChg>
-      </pc:sldChg>
-      <pc:sldChg chg="modSp mod">
-        <pc:chgData name="nakamura takuya" userId="727bb4a0-377a-4a8e-a89d-8efa14875c2f" providerId="ADAL" clId="{7D6FC31F-3357-4373-B706-004F3C0B89A4}" dt="2026-07-08T07:35:41.779" v="188" actId="14100"/>
-        <pc:sldMkLst>
-          <pc:docMk/>
-          <pc:sldMk cId="461094955" sldId="289"/>
-        </pc:sldMkLst>
-        <pc:spChg chg="mod">
-          <ac:chgData name="nakamura takuya" userId="727bb4a0-377a-4a8e-a89d-8efa14875c2f" providerId="ADAL" clId="{7D6FC31F-3357-4373-B706-004F3C0B89A4}" dt="2026-07-08T07:35:41.779" v="188" actId="14100"/>
-          <ac:spMkLst>
-            <pc:docMk/>
-            <pc:sldMk cId="461094955" sldId="289"/>
-            <ac:spMk id="9" creationId="{AD2164AE-11C3-C558-A238-BB8B4162993B}"/>
-          </ac:spMkLst>
-        </pc:spChg>
-        <pc:spChg chg="mod">
-          <ac:chgData name="nakamura takuya" userId="727bb4a0-377a-4a8e-a89d-8efa14875c2f" providerId="ADAL" clId="{7D6FC31F-3357-4373-B706-004F3C0B89A4}" dt="2026-07-08T07:26:34.354" v="48" actId="20577"/>
-          <ac:spMkLst>
-            <pc:docMk/>
-            <pc:sldMk cId="461094955" sldId="289"/>
-            <ac:spMk id="39" creationId="{E29A8316-9B46-E2FB-CA2C-2DD6C1310603}"/>
-          </ac:spMkLst>
-        </pc:spChg>
-      </pc:sldChg>
-      <pc:sldChg chg="modSp mod">
-        <pc:chgData name="nakamura takuya" userId="727bb4a0-377a-4a8e-a89d-8efa14875c2f" providerId="ADAL" clId="{7D6FC31F-3357-4373-B706-004F3C0B89A4}" dt="2026-07-08T07:31:25.235" v="176" actId="20577"/>
-        <pc:sldMkLst>
-          <pc:docMk/>
-          <pc:sldMk cId="1282037412" sldId="2147483414"/>
-        </pc:sldMkLst>
-        <pc:spChg chg="mod">
-          <ac:chgData name="nakamura takuya" userId="727bb4a0-377a-4a8e-a89d-8efa14875c2f" providerId="ADAL" clId="{7D6FC31F-3357-4373-B706-004F3C0B89A4}" dt="2026-07-08T07:31:25.235" v="176" actId="20577"/>
-          <ac:spMkLst>
-            <pc:docMk/>
-            <pc:sldMk cId="1282037412" sldId="2147483414"/>
-            <ac:spMk id="3" creationId="{9BA3BF88-2A26-4021-9A80-97EA2872AB58}"/>
-          </ac:spMkLst>
-        </pc:spChg>
-      </pc:sldChg>
-      <pc:sldChg chg="modSp mod">
-        <pc:chgData name="nakamura takuya" userId="727bb4a0-377a-4a8e-a89d-8efa14875c2f" providerId="ADAL" clId="{7D6FC31F-3357-4373-B706-004F3C0B89A4}" dt="2026-07-08T07:31:37.723" v="186" actId="20577"/>
-        <pc:sldMkLst>
-          <pc:docMk/>
-          <pc:sldMk cId="545895450" sldId="2147483463"/>
-        </pc:sldMkLst>
-        <pc:spChg chg="mod">
-          <ac:chgData name="nakamura takuya" userId="727bb4a0-377a-4a8e-a89d-8efa14875c2f" providerId="ADAL" clId="{7D6FC31F-3357-4373-B706-004F3C0B89A4}" dt="2026-07-08T07:31:37.723" v="186" actId="20577"/>
-          <ac:spMkLst>
-            <pc:docMk/>
-            <pc:sldMk cId="545895450" sldId="2147483463"/>
-            <ac:spMk id="20" creationId="{D0F78E7B-4139-F202-4FC6-34CFC1BA72DF}"/>
-          </ac:spMkLst>
-        </pc:spChg>
-      </pc:sldChg>
-      <pc:sldChg chg="addSp modSp mod">
-        <pc:chgData name="nakamura takuya" userId="727bb4a0-377a-4a8e-a89d-8efa14875c2f" providerId="ADAL" clId="{7D6FC31F-3357-4373-B706-004F3C0B89A4}" dt="2026-07-08T07:29:07.868" v="156" actId="1076"/>
-        <pc:sldMkLst>
-          <pc:docMk/>
-          <pc:sldMk cId="1508688980" sldId="2147483557"/>
-        </pc:sldMkLst>
-        <pc:spChg chg="add mod">
-          <ac:chgData name="nakamura takuya" userId="727bb4a0-377a-4a8e-a89d-8efa14875c2f" providerId="ADAL" clId="{7D6FC31F-3357-4373-B706-004F3C0B89A4}" dt="2026-07-08T07:29:07.868" v="156" actId="1076"/>
-          <ac:spMkLst>
-            <pc:docMk/>
-            <pc:sldMk cId="1508688980" sldId="2147483557"/>
-            <ac:spMk id="5" creationId="{5D5B3E60-E86F-0CF0-3CB2-96835F7BDBC4}"/>
-          </ac:spMkLst>
-        </pc:spChg>
-      </pc:sldChg>
-      <pc:sldChg chg="modSp mod">
-        <pc:chgData name="nakamura takuya" userId="727bb4a0-377a-4a8e-a89d-8efa14875c2f" providerId="ADAL" clId="{7D6FC31F-3357-4373-B706-004F3C0B89A4}" dt="2026-07-08T07:29:46.790" v="170" actId="20577"/>
-        <pc:sldMkLst>
-          <pc:docMk/>
-          <pc:sldMk cId="4247146017" sldId="2147483644"/>
-        </pc:sldMkLst>
-        <pc:spChg chg="mod">
-          <ac:chgData name="nakamura takuya" userId="727bb4a0-377a-4a8e-a89d-8efa14875c2f" providerId="ADAL" clId="{7D6FC31F-3357-4373-B706-004F3C0B89A4}" dt="2026-07-08T07:29:46.790" v="170" actId="20577"/>
-          <ac:spMkLst>
-            <pc:docMk/>
-            <pc:sldMk cId="4247146017" sldId="2147483644"/>
-            <ac:spMk id="5" creationId="{5DA63169-80E3-4879-7012-7E04D76F23CF}"/>
-          </ac:spMkLst>
-        </pc:spChg>
-      </pc:sldChg>
-    </pc:docChg>
-  </pc:docChgLst>
-  <pc:docChgLst>
-    <pc:chgData name="伊東 千尋" userId="S::cito_cardnet.co.jp#ext#@lowcodecojp.onmicrosoft.com::35527b19-bb60-4cbd-88f7-e76b000149f9" providerId="AD" clId="Web-{B96FCF50-0429-1EAE-7CA4-12E9A0E019CA}"/>
-    <pc:docChg chg="sldOrd">
-      <pc:chgData name="伊東 千尋" userId="S::cito_cardnet.co.jp#ext#@lowcodecojp.onmicrosoft.com::35527b19-bb60-4cbd-88f7-e76b000149f9" providerId="AD" clId="Web-{B96FCF50-0429-1EAE-7CA4-12E9A0E019CA}" dt="2026-07-09T05:44:16.328" v="3"/>
-      <pc:docMkLst>
-        <pc:docMk/>
-      </pc:docMkLst>
-      <pc:sldChg chg="ord">
-        <pc:chgData name="伊東 千尋" userId="S::cito_cardnet.co.jp#ext#@lowcodecojp.onmicrosoft.com::35527b19-bb60-4cbd-88f7-e76b000149f9" providerId="AD" clId="Web-{B96FCF50-0429-1EAE-7CA4-12E9A0E019CA}" dt="2026-07-09T00:04:59.907" v="0"/>
-        <pc:sldMkLst>
-          <pc:docMk/>
-          <pc:sldMk cId="2217997272" sldId="263"/>
-        </pc:sldMkLst>
-      </pc:sldChg>
-      <pc:sldChg chg="ord">
-        <pc:chgData name="伊東 千尋" userId="S::cito_cardnet.co.jp#ext#@lowcodecojp.onmicrosoft.com::35527b19-bb60-4cbd-88f7-e76b000149f9" providerId="AD" clId="Web-{B96FCF50-0429-1EAE-7CA4-12E9A0E019CA}" dt="2026-07-09T00:05:28.564" v="1"/>
-        <pc:sldMkLst>
-          <pc:docMk/>
-          <pc:sldMk cId="281921604" sldId="275"/>
-        </pc:sldMkLst>
-      </pc:sldChg>
-      <pc:sldChg chg="ord">
-        <pc:chgData name="伊東 千尋" userId="S::cito_cardnet.co.jp#ext#@lowcodecojp.onmicrosoft.com::35527b19-bb60-4cbd-88f7-e76b000149f9" providerId="AD" clId="Web-{B96FCF50-0429-1EAE-7CA4-12E9A0E019CA}" dt="2026-07-09T05:44:14.860" v="2"/>
-        <pc:sldMkLst>
-          <pc:docMk/>
-          <pc:sldMk cId="1282037412" sldId="2147483414"/>
-        </pc:sldMkLst>
-      </pc:sldChg>
-      <pc:sldChg chg="ord">
-        <pc:chgData name="伊東 千尋" userId="S::cito_cardnet.co.jp#ext#@lowcodecojp.onmicrosoft.com::35527b19-bb60-4cbd-88f7-e76b000149f9" providerId="AD" clId="Web-{B96FCF50-0429-1EAE-7CA4-12E9A0E019CA}" dt="2026-07-09T05:44:16.328" v="3"/>
-        <pc:sldMkLst>
-          <pc:docMk/>
-          <pc:sldMk cId="3539835541" sldId="2147483545"/>
-        </pc:sldMkLst>
-      </pc:sldChg>
-    </pc:docChg>
-  </pc:docChgLst>
-  <pc:docChgLst>
-    <pc:chgData name="伊東 千尋" userId="S::cito_cardnet.co.jp#ext#@lowcodecojp.onmicrosoft.com::35527b19-bb60-4cbd-88f7-e76b000149f9" providerId="AD" clId="Web-{B25FB36F-E0EA-7BCA-5154-982983B7251B}"/>
-    <pc:docChg chg="modSld">
-      <pc:chgData name="伊東 千尋" userId="S::cito_cardnet.co.jp#ext#@lowcodecojp.onmicrosoft.com::35527b19-bb60-4cbd-88f7-e76b000149f9" providerId="AD" clId="Web-{B25FB36F-E0EA-7BCA-5154-982983B7251B}" dt="2026-07-16T04:13:22.965" v="0" actId="1076"/>
-      <pc:docMkLst>
-        <pc:docMk/>
-      </pc:docMkLst>
-      <pc:sldChg chg="modSp">
-        <pc:chgData name="伊東 千尋" userId="S::cito_cardnet.co.jp#ext#@lowcodecojp.onmicrosoft.com::35527b19-bb60-4cbd-88f7-e76b000149f9" providerId="AD" clId="Web-{B25FB36F-E0EA-7BCA-5154-982983B7251B}" dt="2026-07-16T04:13:22.965" v="0" actId="1076"/>
-        <pc:sldMkLst>
-          <pc:docMk/>
-          <pc:sldMk cId="4195799110" sldId="273"/>
-        </pc:sldMkLst>
-        <pc:spChg chg="mod">
-          <ac:chgData name="伊東 千尋" userId="S::cito_cardnet.co.jp#ext#@lowcodecojp.onmicrosoft.com::35527b19-bb60-4cbd-88f7-e76b000149f9" providerId="AD" clId="Web-{B25FB36F-E0EA-7BCA-5154-982983B7251B}" dt="2026-07-16T04:13:22.965" v="0" actId="1076"/>
-          <ac:spMkLst>
-            <pc:docMk/>
-            <pc:sldMk cId="4195799110" sldId="273"/>
-            <ac:spMk id="29" creationId="{C9152791-F537-EAA5-4460-63024FAA0B8F}"/>
-          </ac:spMkLst>
-        </pc:spChg>
-      </pc:sldChg>
-    </pc:docChg>
-  </pc:docChgLst>
-</pc:chgInfo>
 </file>
 
 <file path=ppt/notesMasters/notesMaster1.xml><?xml version="1.0" encoding="utf-8"?>

</xml_diff>

<commit_message>
Redesign meeting deck (3 slides) with polished schedule timeline
ユーザー版のデザインを刷新。テンプレートの配色（ティール＋コーラル）で
統一し、内容はそのままに視認性を向上。

- スライド1: タイトル（アクセントバー＋タグ＋日付・チーム数）
- スライド2: 本日のポイント（目的／ガイドライン準拠確認の2カード）
- スライド3: 全体スケジュール（マイルストーン付きタイムライン＋
  月別カード＋メンター支援リボンで8〜9月の定例会を表現）

各スライドのPNG画像も docs/ に追加。

Co-Authored-By: Claude Opus 4.8 <noreply@anthropic.com>
Claude-Session: https://claude.ai/code/session_01JPzR9PgdjEvTujeJxwKNpL
</commit_message>
<xml_diff>
--- a/docs/コパイロットスタジオ_事前相談会②_会議資料.pptx
+++ b/docs/コパイロットスタジオ_事前相談会②_会議資料.pptx
@@ -7,6 +7,7 @@
   <p:sldIdLst>
     <p:sldId id="256" r:id="rId7"/>
     <p:sldId id="257" r:id="rId8"/>
+    <p:sldId id="258" r:id="rId9"/>
   </p:sldIdLst>
   <p:sldSz cx="13439775" cy="7559675" type="screen4x3"/>
   <p:notesSz cx="6858000" cy="9144000"/>
@@ -3091,58 +3092,14 @@
       <p:grpSpPr/>
       <p:sp>
         <p:nvSpPr>
-          <p:cNvPr id="2" name="TextBox 1"/>
-          <p:cNvSpPr txBox="1"/>
-          <p:nvPr/>
-        </p:nvSpPr>
-        <p:spPr>
-          <a:xfrm>
-            <a:off x="814546" y="360000"/>
-            <a:ext cx="11810918" cy="470000"/>
-          </a:xfrm>
-          <a:prstGeom prst="rect">
-            <a:avLst/>
-          </a:prstGeom>
-          <a:noFill/>
-        </p:spPr>
-        <p:txBody>
-          <a:bodyPr wrap="square" anchor="ctr" lIns="0" rIns="0" tIns="0" bIns="0">
-            <a:spAutoFit/>
-          </a:bodyPr>
-          <a:lstStyle/>
-          <a:p>
-            <a:pPr algn="l">
-              <a:lnSpc>
-                <a:spcPct val="100000"/>
-              </a:lnSpc>
-              <a:spcAft>
-                <a:spcPts val="0"/>
-              </a:spcAft>
-            </a:pPr>
-            <a:r>
-              <a:rPr sz="2600" b="1">
-                <a:solidFill>
-                  <a:srgbClr val="232323"/>
-                </a:solidFill>
-                <a:latin typeface="游ゴシック"/>
-                <a:ea typeface="游ゴシック"/>
-                <a:cs typeface="游ゴシック"/>
-              </a:rPr>
-              <a:t>全体スケジュール（7月〜10月上旬）</a:t>
-            </a:r>
-          </a:p>
-        </p:txBody>
-      </p:sp>
-      <p:sp>
-        <p:nvSpPr>
-          <p:cNvPr id="3" name="Rectangle 2"/>
+          <p:cNvPr id="2" name="Rectangle 1"/>
           <p:cNvSpPr/>
           <p:nvPr/>
         </p:nvSpPr>
         <p:spPr>
           <a:xfrm>
-            <a:off x="797689" y="809974"/>
-            <a:ext cx="11827398" cy="89379"/>
+            <a:off x="995000" y="2280000"/>
+            <a:ext cx="105000" cy="2760000"/>
           </a:xfrm>
           <a:prstGeom prst="rect">
             <a:avLst/>
@@ -3179,1124 +3136,14 @@
       </p:sp>
       <p:sp>
         <p:nvSpPr>
-          <p:cNvPr id="4" name="TextBox 3"/>
-          <p:cNvSpPr txBox="1"/>
-          <p:nvPr/>
-        </p:nvSpPr>
-        <p:spPr>
-          <a:xfrm>
-            <a:off x="300000" y="7150000"/>
-            <a:ext cx="7000000" cy="300000"/>
-          </a:xfrm>
-          <a:prstGeom prst="rect">
-            <a:avLst/>
-          </a:prstGeom>
-          <a:noFill/>
-        </p:spPr>
-        <p:txBody>
-          <a:bodyPr wrap="square" anchor="ctr" lIns="0" rIns="0" tIns="0" bIns="0">
-            <a:spAutoFit/>
-          </a:bodyPr>
-          <a:lstStyle/>
-          <a:p>
-            <a:pPr algn="l">
-              <a:lnSpc>
-                <a:spcPct val="100000"/>
-              </a:lnSpc>
-              <a:spcAft>
-                <a:spcPts val="0"/>
-              </a:spcAft>
-            </a:pPr>
-            <a:r>
-              <a:rPr sz="900" b="0">
-                <a:solidFill>
-                  <a:srgbClr val="AEB8BD"/>
-                </a:solidFill>
-                <a:latin typeface="游ゴシック"/>
-                <a:ea typeface="游ゴシック"/>
-                <a:cs typeface="游ゴシック"/>
-              </a:rPr>
-              <a:t>© 2026 Low Code Inc. All rights reserved.</a:t>
-            </a:r>
-          </a:p>
-        </p:txBody>
-      </p:sp>
-      <p:sp>
-        <p:nvSpPr>
-          <p:cNvPr id="5" name="TextBox 4"/>
-          <p:cNvSpPr txBox="1"/>
-          <p:nvPr/>
-        </p:nvSpPr>
-        <p:spPr>
-          <a:xfrm>
-            <a:off x="12650000" y="7057560"/>
-            <a:ext cx="543031" cy="360000"/>
-          </a:xfrm>
-          <a:prstGeom prst="rect">
-            <a:avLst/>
-          </a:prstGeom>
-          <a:noFill/>
-        </p:spPr>
-        <p:txBody>
-          <a:bodyPr wrap="square" anchor="ctr" lIns="0" rIns="0" tIns="0" bIns="0">
-            <a:spAutoFit/>
-          </a:bodyPr>
-          <a:lstStyle/>
-          <a:p>
-            <a:pPr algn="ctr">
-              <a:lnSpc>
-                <a:spcPct val="100000"/>
-              </a:lnSpc>
-              <a:spcAft>
-                <a:spcPts val="0"/>
-              </a:spcAft>
-            </a:pPr>
-            <a:r>
-              <a:rPr sz="1100" b="0">
-                <a:solidFill>
-                  <a:srgbClr val="9BA7AC"/>
-                </a:solidFill>
-                <a:latin typeface="游ゴシック"/>
-                <a:ea typeface="游ゴシック"/>
-                <a:cs typeface="游ゴシック"/>
-              </a:rPr>
-              <a:t>1</a:t>
-            </a:r>
-          </a:p>
-        </p:txBody>
-      </p:sp>
-      <p:sp>
-        <p:nvSpPr>
-          <p:cNvPr id="6" name="TextBox 5"/>
-          <p:cNvSpPr txBox="1"/>
-          <p:nvPr/>
-        </p:nvSpPr>
-        <p:spPr>
-          <a:xfrm>
-            <a:off x="814546" y="990000"/>
-            <a:ext cx="11810918" cy="560000"/>
-          </a:xfrm>
-          <a:prstGeom prst="rect">
-            <a:avLst/>
-          </a:prstGeom>
-          <a:noFill/>
-        </p:spPr>
-        <p:txBody>
-          <a:bodyPr wrap="square" anchor="t" lIns="0" rIns="0" tIns="0" bIns="0">
-            <a:spAutoFit/>
-          </a:bodyPr>
-          <a:lstStyle/>
-          <a:p>
-            <a:pPr algn="l">
-              <a:lnSpc>
-                <a:spcPct val="115000"/>
-              </a:lnSpc>
-              <a:spcAft>
-                <a:spcPts val="0"/>
-              </a:spcAft>
-            </a:pPr>
-            <a:r>
-              <a:rPr sz="1450" b="1">
-                <a:solidFill>
-                  <a:srgbClr val="1B5C80"/>
-                </a:solidFill>
-                <a:latin typeface="游ゴシック"/>
-                <a:ea typeface="游ゴシック"/>
-                <a:cs typeface="游ゴシック"/>
-              </a:rPr>
-              <a:t>全11チーム（各3〜4名）</a:t>
-            </a:r>
-            <a:r>
-              <a:rPr sz="1450" b="0">
-                <a:solidFill>
-                  <a:srgbClr val="232323"/>
-                </a:solidFill>
-                <a:latin typeface="游ゴシック"/>
-                <a:ea typeface="游ゴシック"/>
-                <a:cs typeface="游ゴシック"/>
-              </a:rPr>
-              <a:t>でそれぞれ1つの企画書を作成し、</a:t>
-            </a:r>
-            <a:r>
-              <a:rPr sz="1450" b="1">
-                <a:solidFill>
-                  <a:srgbClr val="EC856F"/>
-                </a:solidFill>
-                <a:latin typeface="游ゴシック"/>
-                <a:ea typeface="游ゴシック"/>
-                <a:cs typeface="游ゴシック"/>
-              </a:rPr>
-              <a:t>10月上旬の社長・役員報告</a:t>
-            </a:r>
-            <a:r>
-              <a:rPr sz="1450" b="0">
-                <a:solidFill>
-                  <a:srgbClr val="232323"/>
-                </a:solidFill>
-                <a:latin typeface="游ゴシック"/>
-                <a:ea typeface="游ゴシック"/>
-                <a:cs typeface="游ゴシック"/>
-              </a:rPr>
-              <a:t>を目指します。</a:t>
-            </a:r>
-          </a:p>
-        </p:txBody>
-      </p:sp>
-      <p:sp>
-        <p:nvSpPr>
-          <p:cNvPr id="7" name="Rounded Rectangle 6"/>
+          <p:cNvPr id="3" name="Rounded Rectangle 2"/>
           <p:cNvSpPr/>
           <p:nvPr/>
         </p:nvSpPr>
         <p:spPr>
           <a:xfrm>
-            <a:off x="814546" y="1660000"/>
-            <a:ext cx="2787729" cy="4620000"/>
-          </a:xfrm>
-          <a:prstGeom prst="roundRect">
-            <a:avLst>
-              <a:gd name="adj" fmla="val 5000"/>
-            </a:avLst>
-          </a:prstGeom>
-          <a:solidFill>
-            <a:srgbClr val="EAF6FB"/>
-          </a:solidFill>
-          <a:ln w="9525">
-            <a:solidFill>
-              <a:srgbClr val="9FD8EA"/>
-            </a:solidFill>
-          </a:ln>
-          <a:effectLst/>
-          <a:effectLst>
-            <a:outerShdw blurRad="50800" dist="25400" dir="5400000" rotWithShape="0">
-              <a:srgbClr val="8AA6B0">
-                <a:alpha val="38000"/>
-              </a:srgbClr>
-            </a:outerShdw>
-          </a:effectLst>
-        </p:spPr>
-        <p:style>
-          <a:lnRef idx="1">
-            <a:schemeClr val="accent1"/>
-          </a:lnRef>
-          <a:fillRef idx="3">
-            <a:schemeClr val="accent1"/>
-          </a:fillRef>
-          <a:effectRef idx="2">
-            <a:schemeClr val="accent1"/>
-          </a:effectRef>
-          <a:fontRef idx="minor">
-            <a:schemeClr val="lt1"/>
-          </a:fontRef>
-        </p:style>
-        <p:txBody>
-          <a:bodyPr rtlCol="0" anchor="ctr" wrap="square"/>
-          <a:lstStyle/>
-          <a:p>
-            <a:pPr algn="ctr"/>
-          </a:p>
-        </p:txBody>
-      </p:sp>
-      <p:sp>
-        <p:nvSpPr>
-          <p:cNvPr id="8" name="TextBox 7"/>
-          <p:cNvSpPr txBox="1"/>
-          <p:nvPr/>
-        </p:nvSpPr>
-        <p:spPr>
-          <a:xfrm>
-            <a:off x="1004546" y="1860000"/>
-            <a:ext cx="2407729" cy="560000"/>
-          </a:xfrm>
-          <a:prstGeom prst="rect">
-            <a:avLst/>
-          </a:prstGeom>
-          <a:noFill/>
-        </p:spPr>
-        <p:txBody>
-          <a:bodyPr wrap="square" anchor="t" lIns="0" rIns="0" tIns="0" bIns="0">
-            <a:spAutoFit/>
-          </a:bodyPr>
-          <a:lstStyle/>
-          <a:p>
-            <a:pPr algn="l">
-              <a:lnSpc>
-                <a:spcPct val="100000"/>
-              </a:lnSpc>
-              <a:spcAft>
-                <a:spcPts val="0"/>
-              </a:spcAft>
-            </a:pPr>
-            <a:r>
-              <a:rPr sz="2500" b="1">
-                <a:solidFill>
-                  <a:srgbClr val="0FA4CC"/>
-                </a:solidFill>
-                <a:latin typeface="游ゴシック"/>
-                <a:ea typeface="游ゴシック"/>
-                <a:cs typeface="游ゴシック"/>
-              </a:rPr>
-              <a:t>7月</a:t>
-            </a:r>
-          </a:p>
-        </p:txBody>
-      </p:sp>
-      <p:sp>
-        <p:nvSpPr>
-          <p:cNvPr id="9" name="Rounded Rectangle 8"/>
-          <p:cNvSpPr/>
-          <p:nvPr/>
-        </p:nvSpPr>
-        <p:spPr>
-          <a:xfrm>
-            <a:off x="1004546" y="2440000"/>
-            <a:ext cx="2407729" cy="470000"/>
-          </a:xfrm>
-          <a:prstGeom prst="roundRect">
-            <a:avLst>
-              <a:gd name="adj" fmla="val 50000"/>
-            </a:avLst>
-          </a:prstGeom>
-          <a:solidFill>
-            <a:srgbClr val="0FA4CC"/>
-          </a:solidFill>
-          <a:ln>
-            <a:noFill/>
-          </a:ln>
-          <a:effectLst/>
-        </p:spPr>
-        <p:style>
-          <a:lnRef idx="1">
-            <a:schemeClr val="accent1"/>
-          </a:lnRef>
-          <a:fillRef idx="3">
-            <a:schemeClr val="accent1"/>
-          </a:fillRef>
-          <a:effectRef idx="2">
-            <a:schemeClr val="accent1"/>
-          </a:effectRef>
-          <a:fontRef idx="minor">
-            <a:schemeClr val="lt1"/>
-          </a:fontRef>
-        </p:style>
-        <p:txBody>
-          <a:bodyPr rtlCol="0" anchor="ctr" wrap="square" lIns="60000" rIns="60000" tIns="0" bIns="0"/>
-          <a:lstStyle/>
-          <a:p>
-            <a:pPr algn="ctr">
-              <a:lnSpc>
-                <a:spcPct val="100000"/>
-              </a:lnSpc>
-              <a:spcAft>
-                <a:spcPts val="0"/>
-              </a:spcAft>
-            </a:pPr>
-            <a:r>
-              <a:rPr sz="1050" b="1">
-                <a:solidFill>
-                  <a:srgbClr val="FFFFFF"/>
-                </a:solidFill>
-                <a:latin typeface="游ゴシック"/>
-                <a:ea typeface="游ゴシック"/>
-                <a:cs typeface="游ゴシック"/>
-              </a:rPr>
-              <a:t>★ 本日：事前相談会②</a:t>
-            </a:r>
-          </a:p>
-        </p:txBody>
-      </p:sp>
-      <p:sp>
-        <p:nvSpPr>
-          <p:cNvPr id="10" name="TextBox 9"/>
-          <p:cNvSpPr txBox="1"/>
-          <p:nvPr/>
-        </p:nvSpPr>
-        <p:spPr>
-          <a:xfrm>
-            <a:off x="1004546" y="3060000"/>
-            <a:ext cx="2407729" cy="2990000"/>
-          </a:xfrm>
-          <a:prstGeom prst="rect">
-            <a:avLst/>
-          </a:prstGeom>
-          <a:noFill/>
-        </p:spPr>
-        <p:txBody>
-          <a:bodyPr wrap="square" anchor="ctr" lIns="0" rIns="0" tIns="0" bIns="0">
-            <a:spAutoFit/>
-          </a:bodyPr>
-          <a:lstStyle/>
-          <a:p>
-            <a:pPr algn="l">
-              <a:lnSpc>
-                <a:spcPct val="116000"/>
-              </a:lnSpc>
-              <a:spcAft>
-                <a:spcPts val="1700"/>
-              </a:spcAft>
-            </a:pPr>
-            <a:r>
-              <a:rPr sz="950" b="0">
-                <a:solidFill>
-                  <a:srgbClr val="0FA4CC"/>
-                </a:solidFill>
-                <a:latin typeface="游ゴシック"/>
-                <a:ea typeface="游ゴシック"/>
-                <a:cs typeface="游ゴシック"/>
-              </a:rPr>
-              <a:t>● </a:t>
-            </a:r>
-            <a:r>
-              <a:rPr sz="1300" b="0">
-                <a:solidFill>
-                  <a:srgbClr val="232323"/>
-                </a:solidFill>
-                <a:latin typeface="游ゴシック"/>
-                <a:ea typeface="游ゴシック"/>
-                <a:cs typeface="游ゴシック"/>
-              </a:rPr>
-              <a:t>チーム編成・企画案の作成</a:t>
-            </a:r>
-          </a:p>
-          <a:p>
-            <a:pPr algn="l">
-              <a:lnSpc>
-                <a:spcPct val="116000"/>
-              </a:lnSpc>
-              <a:spcAft>
-                <a:spcPts val="1700"/>
-              </a:spcAft>
-            </a:pPr>
-            <a:r>
-              <a:rPr sz="950" b="0">
-                <a:solidFill>
-                  <a:srgbClr val="0FA4CC"/>
-                </a:solidFill>
-                <a:latin typeface="游ゴシック"/>
-                <a:ea typeface="游ゴシック"/>
-                <a:cs typeface="游ゴシック"/>
-              </a:rPr>
-              <a:t>● </a:t>
-            </a:r>
-            <a:r>
-              <a:rPr sz="1300" b="0">
-                <a:solidFill>
-                  <a:srgbClr val="232323"/>
-                </a:solidFill>
-                <a:latin typeface="游ゴシック"/>
-                <a:ea typeface="游ゴシック"/>
-                <a:cs typeface="游ゴシック"/>
-              </a:rPr>
-              <a:t>Copilot Studio／Power Automate 研修</a:t>
-            </a:r>
-          </a:p>
-          <a:p>
-            <a:pPr algn="l">
-              <a:lnSpc>
-                <a:spcPct val="116000"/>
-              </a:lnSpc>
-              <a:spcAft>
-                <a:spcPts val="1700"/>
-              </a:spcAft>
-            </a:pPr>
-            <a:r>
-              <a:rPr sz="950" b="0">
-                <a:solidFill>
-                  <a:srgbClr val="0FA4CC"/>
-                </a:solidFill>
-                <a:latin typeface="游ゴシック"/>
-                <a:ea typeface="游ゴシック"/>
-                <a:cs typeface="游ゴシック"/>
-              </a:rPr>
-              <a:t>● </a:t>
-            </a:r>
-            <a:r>
-              <a:rPr sz="1300" b="0">
-                <a:solidFill>
-                  <a:srgbClr val="232323"/>
-                </a:solidFill>
-                <a:latin typeface="游ゴシック"/>
-                <a:ea typeface="游ゴシック"/>
-                <a:cs typeface="游ゴシック"/>
-              </a:rPr>
-              <a:t>メンター事前相談会 ①・②</a:t>
-            </a:r>
-          </a:p>
-        </p:txBody>
-      </p:sp>
-      <p:sp>
-        <p:nvSpPr>
-          <p:cNvPr id="11" name="Rounded Rectangle 10"/>
-          <p:cNvSpPr/>
-          <p:nvPr/>
-        </p:nvSpPr>
-        <p:spPr>
-          <a:xfrm>
-            <a:off x="3822275" y="1660000"/>
-            <a:ext cx="2787729" cy="4620000"/>
-          </a:xfrm>
-          <a:prstGeom prst="roundRect">
-            <a:avLst>
-              <a:gd name="adj" fmla="val 5000"/>
-            </a:avLst>
-          </a:prstGeom>
-          <a:solidFill>
-            <a:srgbClr val="EAF6FB"/>
-          </a:solidFill>
-          <a:ln w="9525">
-            <a:solidFill>
-              <a:srgbClr val="9FD8EA"/>
-            </a:solidFill>
-          </a:ln>
-          <a:effectLst/>
-          <a:effectLst>
-            <a:outerShdw blurRad="50800" dist="25400" dir="5400000" rotWithShape="0">
-              <a:srgbClr val="8AA6B0">
-                <a:alpha val="38000"/>
-              </a:srgbClr>
-            </a:outerShdw>
-          </a:effectLst>
-        </p:spPr>
-        <p:style>
-          <a:lnRef idx="1">
-            <a:schemeClr val="accent1"/>
-          </a:lnRef>
-          <a:fillRef idx="3">
-            <a:schemeClr val="accent1"/>
-          </a:fillRef>
-          <a:effectRef idx="2">
-            <a:schemeClr val="accent1"/>
-          </a:effectRef>
-          <a:fontRef idx="minor">
-            <a:schemeClr val="lt1"/>
-          </a:fontRef>
-        </p:style>
-        <p:txBody>
-          <a:bodyPr rtlCol="0" anchor="ctr" wrap="square"/>
-          <a:lstStyle/>
-          <a:p>
-            <a:pPr algn="ctr"/>
-          </a:p>
-        </p:txBody>
-      </p:sp>
-      <p:sp>
-        <p:nvSpPr>
-          <p:cNvPr id="12" name="TextBox 11"/>
-          <p:cNvSpPr txBox="1"/>
-          <p:nvPr/>
-        </p:nvSpPr>
-        <p:spPr>
-          <a:xfrm>
-            <a:off x="4012275" y="1860000"/>
-            <a:ext cx="2407729" cy="560000"/>
-          </a:xfrm>
-          <a:prstGeom prst="rect">
-            <a:avLst/>
-          </a:prstGeom>
-          <a:noFill/>
-        </p:spPr>
-        <p:txBody>
-          <a:bodyPr wrap="square" anchor="t" lIns="0" rIns="0" tIns="0" bIns="0">
-            <a:spAutoFit/>
-          </a:bodyPr>
-          <a:lstStyle/>
-          <a:p>
-            <a:pPr algn="l">
-              <a:lnSpc>
-                <a:spcPct val="100000"/>
-              </a:lnSpc>
-              <a:spcAft>
-                <a:spcPts val="0"/>
-              </a:spcAft>
-            </a:pPr>
-            <a:r>
-              <a:rPr sz="2500" b="1">
-                <a:solidFill>
-                  <a:srgbClr val="0FA4CC"/>
-                </a:solidFill>
-                <a:latin typeface="游ゴシック"/>
-                <a:ea typeface="游ゴシック"/>
-                <a:cs typeface="游ゴシック"/>
-              </a:rPr>
-              <a:t>8月</a:t>
-            </a:r>
-          </a:p>
-        </p:txBody>
-      </p:sp>
-      <p:sp>
-        <p:nvSpPr>
-          <p:cNvPr id="13" name="Rounded Rectangle 12"/>
-          <p:cNvSpPr/>
-          <p:nvPr/>
-        </p:nvSpPr>
-        <p:spPr>
-          <a:xfrm>
-            <a:off x="4012275" y="2440000"/>
-            <a:ext cx="2407729" cy="470000"/>
-          </a:xfrm>
-          <a:prstGeom prst="roundRect">
-            <a:avLst>
-              <a:gd name="adj" fmla="val 50000"/>
-            </a:avLst>
-          </a:prstGeom>
-          <a:solidFill>
-            <a:srgbClr val="0FA4CC"/>
-          </a:solidFill>
-          <a:ln>
-            <a:noFill/>
-          </a:ln>
-          <a:effectLst/>
-        </p:spPr>
-        <p:style>
-          <a:lnRef idx="1">
-            <a:schemeClr val="accent1"/>
-          </a:lnRef>
-          <a:fillRef idx="3">
-            <a:schemeClr val="accent1"/>
-          </a:fillRef>
-          <a:effectRef idx="2">
-            <a:schemeClr val="accent1"/>
-          </a:effectRef>
-          <a:fontRef idx="minor">
-            <a:schemeClr val="lt1"/>
-          </a:fontRef>
-        </p:style>
-        <p:txBody>
-          <a:bodyPr rtlCol="0" anchor="ctr" wrap="square" lIns="60000" rIns="60000" tIns="0" bIns="0"/>
-          <a:lstStyle/>
-          <a:p>
-            <a:pPr algn="ctr">
-              <a:lnSpc>
-                <a:spcPct val="100000"/>
-              </a:lnSpc>
-              <a:spcAft>
-                <a:spcPts val="0"/>
-              </a:spcAft>
-            </a:pPr>
-            <a:r>
-              <a:rPr sz="1050" b="1">
-                <a:solidFill>
-                  <a:srgbClr val="FFFFFF"/>
-                </a:solidFill>
-                <a:latin typeface="游ゴシック"/>
-                <a:ea typeface="游ゴシック"/>
-                <a:cs typeface="游ゴシック"/>
-              </a:rPr>
-              <a:t>8月初旬：ライセンス付与</a:t>
-            </a:r>
-          </a:p>
-        </p:txBody>
-      </p:sp>
-      <p:sp>
-        <p:nvSpPr>
-          <p:cNvPr id="14" name="TextBox 13"/>
-          <p:cNvSpPr txBox="1"/>
-          <p:nvPr/>
-        </p:nvSpPr>
-        <p:spPr>
-          <a:xfrm>
-            <a:off x="4012275" y="3060000"/>
-            <a:ext cx="2407729" cy="2990000"/>
-          </a:xfrm>
-          <a:prstGeom prst="rect">
-            <a:avLst/>
-          </a:prstGeom>
-          <a:noFill/>
-        </p:spPr>
-        <p:txBody>
-          <a:bodyPr wrap="square" anchor="ctr" lIns="0" rIns="0" tIns="0" bIns="0">
-            <a:spAutoFit/>
-          </a:bodyPr>
-          <a:lstStyle/>
-          <a:p>
-            <a:pPr algn="l">
-              <a:lnSpc>
-                <a:spcPct val="116000"/>
-              </a:lnSpc>
-              <a:spcAft>
-                <a:spcPts val="1700"/>
-              </a:spcAft>
-            </a:pPr>
-            <a:r>
-              <a:rPr sz="950" b="0">
-                <a:solidFill>
-                  <a:srgbClr val="0FA4CC"/>
-                </a:solidFill>
-                <a:latin typeface="游ゴシック"/>
-                <a:ea typeface="游ゴシック"/>
-                <a:cs typeface="游ゴシック"/>
-              </a:rPr>
-              <a:t>● </a:t>
-            </a:r>
-            <a:r>
-              <a:rPr sz="1300" b="0">
-                <a:solidFill>
-                  <a:srgbClr val="232323"/>
-                </a:solidFill>
-                <a:latin typeface="游ゴシック"/>
-                <a:ea typeface="游ゴシック"/>
-                <a:cs typeface="游ゴシック"/>
-              </a:rPr>
-              <a:t>チームごとに構築・検証</a:t>
-            </a:r>
-          </a:p>
-          <a:p>
-            <a:pPr algn="l">
-              <a:lnSpc>
-                <a:spcPct val="116000"/>
-              </a:lnSpc>
-              <a:spcAft>
-                <a:spcPts val="1700"/>
-              </a:spcAft>
-            </a:pPr>
-            <a:r>
-              <a:rPr sz="950" b="0">
-                <a:solidFill>
-                  <a:srgbClr val="0FA4CC"/>
-                </a:solidFill>
-                <a:latin typeface="游ゴシック"/>
-                <a:ea typeface="游ゴシック"/>
-                <a:cs typeface="游ゴシック"/>
-              </a:rPr>
-              <a:t>● </a:t>
-            </a:r>
-            <a:r>
-              <a:rPr sz="1300" b="0">
-                <a:solidFill>
-                  <a:srgbClr val="232323"/>
-                </a:solidFill>
-                <a:latin typeface="游ゴシック"/>
-                <a:ea typeface="游ゴシック"/>
-                <a:cs typeface="游ゴシック"/>
-              </a:rPr>
-              <a:t>メンターとの定例会（週次〜隔週）</a:t>
-            </a:r>
-          </a:p>
-          <a:p>
-            <a:pPr algn="l">
-              <a:lnSpc>
-                <a:spcPct val="116000"/>
-              </a:lnSpc>
-              <a:spcAft>
-                <a:spcPts val="1700"/>
-              </a:spcAft>
-            </a:pPr>
-            <a:r>
-              <a:rPr sz="950" b="0">
-                <a:solidFill>
-                  <a:srgbClr val="0FA4CC"/>
-                </a:solidFill>
-                <a:latin typeface="游ゴシック"/>
-                <a:ea typeface="游ゴシック"/>
-                <a:cs typeface="游ゴシック"/>
-              </a:rPr>
-              <a:t>● </a:t>
-            </a:r>
-            <a:r>
-              <a:rPr sz="1300" b="1">
-                <a:solidFill>
-                  <a:srgbClr val="0FA4CC"/>
-                </a:solidFill>
-                <a:latin typeface="游ゴシック"/>
-                <a:ea typeface="游ゴシック"/>
-                <a:cs typeface="游ゴシック"/>
-              </a:rPr>
-              <a:t>Copilot Studio ライセンス付与見込み</a:t>
-            </a:r>
-          </a:p>
-        </p:txBody>
-      </p:sp>
-      <p:sp>
-        <p:nvSpPr>
-          <p:cNvPr id="15" name="Rounded Rectangle 14"/>
-          <p:cNvSpPr/>
-          <p:nvPr/>
-        </p:nvSpPr>
-        <p:spPr>
-          <a:xfrm>
-            <a:off x="6830004" y="1660000"/>
-            <a:ext cx="2787729" cy="4620000"/>
-          </a:xfrm>
-          <a:prstGeom prst="roundRect">
-            <a:avLst>
-              <a:gd name="adj" fmla="val 5000"/>
-            </a:avLst>
-          </a:prstGeom>
-          <a:solidFill>
-            <a:srgbClr val="EAF6FB"/>
-          </a:solidFill>
-          <a:ln w="9525">
-            <a:solidFill>
-              <a:srgbClr val="9FD8EA"/>
-            </a:solidFill>
-          </a:ln>
-          <a:effectLst/>
-          <a:effectLst>
-            <a:outerShdw blurRad="50800" dist="25400" dir="5400000" rotWithShape="0">
-              <a:srgbClr val="8AA6B0">
-                <a:alpha val="38000"/>
-              </a:srgbClr>
-            </a:outerShdw>
-          </a:effectLst>
-        </p:spPr>
-        <p:style>
-          <a:lnRef idx="1">
-            <a:schemeClr val="accent1"/>
-          </a:lnRef>
-          <a:fillRef idx="3">
-            <a:schemeClr val="accent1"/>
-          </a:fillRef>
-          <a:effectRef idx="2">
-            <a:schemeClr val="accent1"/>
-          </a:effectRef>
-          <a:fontRef idx="minor">
-            <a:schemeClr val="lt1"/>
-          </a:fontRef>
-        </p:style>
-        <p:txBody>
-          <a:bodyPr rtlCol="0" anchor="ctr" wrap="square"/>
-          <a:lstStyle/>
-          <a:p>
-            <a:pPr algn="ctr"/>
-          </a:p>
-        </p:txBody>
-      </p:sp>
-      <p:sp>
-        <p:nvSpPr>
-          <p:cNvPr id="16" name="TextBox 15"/>
-          <p:cNvSpPr txBox="1"/>
-          <p:nvPr/>
-        </p:nvSpPr>
-        <p:spPr>
-          <a:xfrm>
-            <a:off x="7020004" y="1860000"/>
-            <a:ext cx="2407729" cy="560000"/>
-          </a:xfrm>
-          <a:prstGeom prst="rect">
-            <a:avLst/>
-          </a:prstGeom>
-          <a:noFill/>
-        </p:spPr>
-        <p:txBody>
-          <a:bodyPr wrap="square" anchor="t" lIns="0" rIns="0" tIns="0" bIns="0">
-            <a:spAutoFit/>
-          </a:bodyPr>
-          <a:lstStyle/>
-          <a:p>
-            <a:pPr algn="l">
-              <a:lnSpc>
-                <a:spcPct val="100000"/>
-              </a:lnSpc>
-              <a:spcAft>
-                <a:spcPts val="0"/>
-              </a:spcAft>
-            </a:pPr>
-            <a:r>
-              <a:rPr sz="2500" b="1">
-                <a:solidFill>
-                  <a:srgbClr val="0FA4CC"/>
-                </a:solidFill>
-                <a:latin typeface="游ゴシック"/>
-                <a:ea typeface="游ゴシック"/>
-                <a:cs typeface="游ゴシック"/>
-              </a:rPr>
-              <a:t>9月</a:t>
-            </a:r>
-          </a:p>
-        </p:txBody>
-      </p:sp>
-      <p:sp>
-        <p:nvSpPr>
-          <p:cNvPr id="17" name="Rounded Rectangle 16"/>
-          <p:cNvSpPr/>
-          <p:nvPr/>
-        </p:nvSpPr>
-        <p:spPr>
-          <a:xfrm>
-            <a:off x="7020004" y="2440000"/>
-            <a:ext cx="2407729" cy="470000"/>
-          </a:xfrm>
-          <a:prstGeom prst="roundRect">
-            <a:avLst>
-              <a:gd name="adj" fmla="val 50000"/>
-            </a:avLst>
-          </a:prstGeom>
-          <a:solidFill>
-            <a:srgbClr val="0FA4CC"/>
-          </a:solidFill>
-          <a:ln>
-            <a:noFill/>
-          </a:ln>
-          <a:effectLst/>
-        </p:spPr>
-        <p:style>
-          <a:lnRef idx="1">
-            <a:schemeClr val="accent1"/>
-          </a:lnRef>
-          <a:fillRef idx="3">
-            <a:schemeClr val="accent1"/>
-          </a:fillRef>
-          <a:effectRef idx="2">
-            <a:schemeClr val="accent1"/>
-          </a:effectRef>
-          <a:fontRef idx="minor">
-            <a:schemeClr val="lt1"/>
-          </a:fontRef>
-        </p:style>
-        <p:txBody>
-          <a:bodyPr rtlCol="0" anchor="ctr" wrap="square" lIns="60000" rIns="60000" tIns="0" bIns="0"/>
-          <a:lstStyle/>
-          <a:p>
-            <a:pPr algn="ctr">
-              <a:lnSpc>
-                <a:spcPct val="100000"/>
-              </a:lnSpc>
-              <a:spcAft>
-                <a:spcPts val="0"/>
-              </a:spcAft>
-            </a:pPr>
-            <a:r>
-              <a:rPr sz="1050" b="1">
-                <a:solidFill>
-                  <a:srgbClr val="FFFFFF"/>
-                </a:solidFill>
-                <a:latin typeface="游ゴシック"/>
-                <a:ea typeface="游ゴシック"/>
-                <a:cs typeface="游ゴシック"/>
-              </a:rPr>
-              <a:t>社長報告に向けた準備</a:t>
-            </a:r>
-          </a:p>
-        </p:txBody>
-      </p:sp>
-      <p:sp>
-        <p:nvSpPr>
-          <p:cNvPr id="18" name="TextBox 17"/>
-          <p:cNvSpPr txBox="1"/>
-          <p:nvPr/>
-        </p:nvSpPr>
-        <p:spPr>
-          <a:xfrm>
-            <a:off x="7020004" y="3060000"/>
-            <a:ext cx="2407729" cy="2990000"/>
-          </a:xfrm>
-          <a:prstGeom prst="rect">
-            <a:avLst/>
-          </a:prstGeom>
-          <a:noFill/>
-        </p:spPr>
-        <p:txBody>
-          <a:bodyPr wrap="square" anchor="ctr" lIns="0" rIns="0" tIns="0" bIns="0">
-            <a:spAutoFit/>
-          </a:bodyPr>
-          <a:lstStyle/>
-          <a:p>
-            <a:pPr algn="l">
-              <a:lnSpc>
-                <a:spcPct val="116000"/>
-              </a:lnSpc>
-              <a:spcAft>
-                <a:spcPts val="1700"/>
-              </a:spcAft>
-            </a:pPr>
-            <a:r>
-              <a:rPr sz="950" b="0">
-                <a:solidFill>
-                  <a:srgbClr val="0FA4CC"/>
-                </a:solidFill>
-                <a:latin typeface="游ゴシック"/>
-                <a:ea typeface="游ゴシック"/>
-                <a:cs typeface="游ゴシック"/>
-              </a:rPr>
-              <a:t>● </a:t>
-            </a:r>
-            <a:r>
-              <a:rPr sz="1300" b="0">
-                <a:solidFill>
-                  <a:srgbClr val="232323"/>
-                </a:solidFill>
-                <a:latin typeface="游ゴシック"/>
-                <a:ea typeface="游ゴシック"/>
-                <a:cs typeface="游ゴシック"/>
-              </a:rPr>
-              <a:t>構築した仕組みのデモ検証</a:t>
-            </a:r>
-          </a:p>
-          <a:p>
-            <a:pPr algn="l">
-              <a:lnSpc>
-                <a:spcPct val="116000"/>
-              </a:lnSpc>
-              <a:spcAft>
-                <a:spcPts val="1700"/>
-              </a:spcAft>
-            </a:pPr>
-            <a:r>
-              <a:rPr sz="950" b="0">
-                <a:solidFill>
-                  <a:srgbClr val="0FA4CC"/>
-                </a:solidFill>
-                <a:latin typeface="游ゴシック"/>
-                <a:ea typeface="游ゴシック"/>
-                <a:cs typeface="游ゴシック"/>
-              </a:rPr>
-              <a:t>● </a:t>
-            </a:r>
-            <a:r>
-              <a:rPr sz="1300" b="0">
-                <a:solidFill>
-                  <a:srgbClr val="232323"/>
-                </a:solidFill>
-                <a:latin typeface="游ゴシック"/>
-                <a:ea typeface="游ゴシック"/>
-                <a:cs typeface="游ゴシック"/>
-              </a:rPr>
-              <a:t>報告資料の作成</a:t>
-            </a:r>
-          </a:p>
-          <a:p>
-            <a:pPr algn="l">
-              <a:lnSpc>
-                <a:spcPct val="116000"/>
-              </a:lnSpc>
-              <a:spcAft>
-                <a:spcPts val="1700"/>
-              </a:spcAft>
-            </a:pPr>
-            <a:r>
-              <a:rPr sz="950" b="0">
-                <a:solidFill>
-                  <a:srgbClr val="0FA4CC"/>
-                </a:solidFill>
-                <a:latin typeface="游ゴシック"/>
-                <a:ea typeface="游ゴシック"/>
-                <a:cs typeface="游ゴシック"/>
-              </a:rPr>
-              <a:t>● </a:t>
-            </a:r>
-            <a:r>
-              <a:rPr sz="1300" b="0">
-                <a:solidFill>
-                  <a:srgbClr val="232323"/>
-                </a:solidFill>
-                <a:latin typeface="游ゴシック"/>
-                <a:ea typeface="游ゴシック"/>
-                <a:cs typeface="游ゴシック"/>
-              </a:rPr>
-              <a:t>今後の展開に関する検討</a:t>
-            </a:r>
-          </a:p>
-        </p:txBody>
-      </p:sp>
-      <p:sp>
-        <p:nvSpPr>
-          <p:cNvPr id="19" name="Rounded Rectangle 18"/>
-          <p:cNvSpPr/>
-          <p:nvPr/>
-        </p:nvSpPr>
-        <p:spPr>
-          <a:xfrm>
-            <a:off x="9837733" y="1660000"/>
-            <a:ext cx="2787729" cy="4620000"/>
-          </a:xfrm>
-          <a:prstGeom prst="roundRect">
-            <a:avLst>
-              <a:gd name="adj" fmla="val 5000"/>
-            </a:avLst>
-          </a:prstGeom>
-          <a:solidFill>
-            <a:srgbClr val="FCEEE9"/>
-          </a:solidFill>
-          <a:ln w="9525">
-            <a:solidFill>
-              <a:srgbClr val="F0B7A8"/>
-            </a:solidFill>
-          </a:ln>
-          <a:effectLst/>
-          <a:effectLst>
-            <a:outerShdw blurRad="50800" dist="25400" dir="5400000" rotWithShape="0">
-              <a:srgbClr val="8AA6B0">
-                <a:alpha val="38000"/>
-              </a:srgbClr>
-            </a:outerShdw>
-          </a:effectLst>
-        </p:spPr>
-        <p:style>
-          <a:lnRef idx="1">
-            <a:schemeClr val="accent1"/>
-          </a:lnRef>
-          <a:fillRef idx="3">
-            <a:schemeClr val="accent1"/>
-          </a:fillRef>
-          <a:effectRef idx="2">
-            <a:schemeClr val="accent1"/>
-          </a:effectRef>
-          <a:fontRef idx="minor">
-            <a:schemeClr val="lt1"/>
-          </a:fontRef>
-        </p:style>
-        <p:txBody>
-          <a:bodyPr rtlCol="0" anchor="ctr" wrap="square"/>
-          <a:lstStyle/>
-          <a:p>
-            <a:pPr algn="ctr"/>
-          </a:p>
-        </p:txBody>
-      </p:sp>
-      <p:sp>
-        <p:nvSpPr>
-          <p:cNvPr id="20" name="TextBox 19"/>
-          <p:cNvSpPr txBox="1"/>
-          <p:nvPr/>
-        </p:nvSpPr>
-        <p:spPr>
-          <a:xfrm>
-            <a:off x="10027733" y="1860000"/>
-            <a:ext cx="2407729" cy="560000"/>
-          </a:xfrm>
-          <a:prstGeom prst="rect">
-            <a:avLst/>
-          </a:prstGeom>
-          <a:noFill/>
-        </p:spPr>
-        <p:txBody>
-          <a:bodyPr wrap="square" anchor="t" lIns="0" rIns="0" tIns="0" bIns="0">
-            <a:spAutoFit/>
-          </a:bodyPr>
-          <a:lstStyle/>
-          <a:p>
-            <a:pPr algn="l">
-              <a:lnSpc>
-                <a:spcPct val="100000"/>
-              </a:lnSpc>
-              <a:spcAft>
-                <a:spcPts val="0"/>
-              </a:spcAft>
-            </a:pPr>
-            <a:r>
-              <a:rPr sz="2500" b="1">
-                <a:solidFill>
-                  <a:srgbClr val="EC856F"/>
-                </a:solidFill>
-                <a:latin typeface="游ゴシック"/>
-                <a:ea typeface="游ゴシック"/>
-                <a:cs typeface="游ゴシック"/>
-              </a:rPr>
-              <a:t>10月</a:t>
-            </a:r>
-          </a:p>
-        </p:txBody>
-      </p:sp>
-      <p:sp>
-        <p:nvSpPr>
-          <p:cNvPr id="21" name="Rounded Rectangle 20"/>
-          <p:cNvSpPr/>
-          <p:nvPr/>
-        </p:nvSpPr>
-        <p:spPr>
-          <a:xfrm>
-            <a:off x="10027733" y="2440000"/>
-            <a:ext cx="2407729" cy="470000"/>
+            <a:off x="1235000" y="1760000"/>
+            <a:ext cx="3050000" cy="470000"/>
           </a:xfrm>
           <a:prstGeom prst="roundRect">
             <a:avLst>
@@ -4326,7 +3173,7 @@
           </a:fontRef>
         </p:style>
         <p:txBody>
-          <a:bodyPr rtlCol="0" anchor="ctr" wrap="square" lIns="60000" rIns="60000" tIns="0" bIns="0"/>
+          <a:bodyPr rtlCol="0" anchor="ctr" wrap="square" lIns="0" rIns="0" tIns="0" bIns="0"/>
           <a:lstStyle/>
           <a:p>
             <a:pPr algn="ctr">
@@ -4338,7 +3185,7 @@
               </a:spcAft>
             </a:pPr>
             <a:r>
-              <a:rPr sz="1050" b="1">
+              <a:rPr sz="1250" b="1">
                 <a:solidFill>
                   <a:srgbClr val="FFFFFF"/>
                 </a:solidFill>
@@ -4346,21 +3193,21 @@
                 <a:ea typeface="游ゴシック"/>
                 <a:cs typeface="游ゴシック"/>
               </a:rPr>
-              <a:t>【1週目】社長・役員へ報告</a:t>
-            </a:r>
-          </a:p>
-        </p:txBody>
-      </p:sp>
-      <p:sp>
-        <p:nvSpPr>
-          <p:cNvPr id="22" name="TextBox 21"/>
+              <a:t>AI活用 × Power Platform</a:t>
+            </a:r>
+          </a:p>
+        </p:txBody>
+      </p:sp>
+      <p:sp>
+        <p:nvSpPr>
+          <p:cNvPr id="4" name="TextBox 3"/>
           <p:cNvSpPr txBox="1"/>
           <p:nvPr/>
         </p:nvSpPr>
         <p:spPr>
           <a:xfrm>
-            <a:off x="10027733" y="3060000"/>
-            <a:ext cx="2407729" cy="2990000"/>
+            <a:off x="1235000" y="2380000"/>
+            <a:ext cx="10800000" cy="2100000"/>
           </a:xfrm>
           <a:prstGeom prst="rect">
             <a:avLst/>
@@ -4368,6 +3215,126 @@
           <a:noFill/>
         </p:spPr>
         <p:txBody>
+          <a:bodyPr wrap="square" anchor="t" lIns="0" rIns="0" tIns="0" bIns="0">
+            <a:spAutoFit/>
+          </a:bodyPr>
+          <a:lstStyle/>
+          <a:p>
+            <a:pPr algn="l">
+              <a:lnSpc>
+                <a:spcPct val="108000"/>
+              </a:lnSpc>
+              <a:spcAft>
+                <a:spcPts val="600"/>
+              </a:spcAft>
+            </a:pPr>
+            <a:r>
+              <a:rPr sz="4200" b="1">
+                <a:solidFill>
+                  <a:srgbClr val="0FA4CC"/>
+                </a:solidFill>
+                <a:latin typeface="游ゴシック"/>
+                <a:ea typeface="游ゴシック"/>
+                <a:cs typeface="游ゴシック"/>
+              </a:rPr>
+              <a:t>Copilot Studio ハッカソン</a:t>
+            </a:r>
+          </a:p>
+          <a:p>
+            <a:pPr algn="l">
+              <a:lnSpc>
+                <a:spcPct val="108000"/>
+              </a:lnSpc>
+              <a:spcAft>
+                <a:spcPts val="0"/>
+              </a:spcAft>
+            </a:pPr>
+            <a:r>
+              <a:rPr sz="4200" b="1">
+                <a:solidFill>
+                  <a:srgbClr val="1B5C80"/>
+                </a:solidFill>
+                <a:latin typeface="游ゴシック"/>
+                <a:ea typeface="游ゴシック"/>
+                <a:cs typeface="游ゴシック"/>
+              </a:rPr>
+              <a:t>事前相談会 ②</a:t>
+            </a:r>
+          </a:p>
+        </p:txBody>
+      </p:sp>
+      <p:sp>
+        <p:nvSpPr>
+          <p:cNvPr id="5" name="TextBox 4"/>
+          <p:cNvSpPr txBox="1"/>
+          <p:nvPr/>
+        </p:nvSpPr>
+        <p:spPr>
+          <a:xfrm>
+            <a:off x="1250000" y="4640000"/>
+            <a:ext cx="10500000" cy="500000"/>
+          </a:xfrm>
+          <a:prstGeom prst="rect">
+            <a:avLst/>
+          </a:prstGeom>
+          <a:noFill/>
+        </p:spPr>
+        <p:txBody>
+          <a:bodyPr wrap="square" anchor="t" lIns="0" rIns="0" tIns="0" bIns="0">
+            <a:spAutoFit/>
+          </a:bodyPr>
+          <a:lstStyle/>
+          <a:p>
+            <a:pPr algn="l">
+              <a:lnSpc>
+                <a:spcPct val="100000"/>
+              </a:lnSpc>
+              <a:spcAft>
+                <a:spcPts val="0"/>
+              </a:spcAft>
+            </a:pPr>
+            <a:r>
+              <a:rPr sz="1600" b="1">
+                <a:solidFill>
+                  <a:srgbClr val="5A6E77"/>
+                </a:solidFill>
+                <a:latin typeface="游ゴシック"/>
+                <a:ea typeface="游ゴシック"/>
+                <a:cs typeface="游ゴシック"/>
+              </a:rPr>
+              <a:t>2026年7月22日</a:t>
+            </a:r>
+            <a:r>
+              <a:rPr sz="1600" b="0">
+                <a:solidFill>
+                  <a:srgbClr val="5A6E77"/>
+                </a:solidFill>
+                <a:latin typeface="游ゴシック"/>
+                <a:ea typeface="游ゴシック"/>
+                <a:cs typeface="游ゴシック"/>
+              </a:rPr>
+              <a:t>　｜　全11チーム（各3〜4名）　｜　7月〜10月上旬</a:t>
+            </a:r>
+          </a:p>
+        </p:txBody>
+      </p:sp>
+      <p:sp>
+        <p:nvSpPr>
+          <p:cNvPr id="6" name="TextBox 5"/>
+          <p:cNvSpPr txBox="1"/>
+          <p:nvPr/>
+        </p:nvSpPr>
+        <p:spPr>
+          <a:xfrm>
+            <a:off x="300000" y="7150000"/>
+            <a:ext cx="7000000" cy="300000"/>
+          </a:xfrm>
+          <a:prstGeom prst="rect">
+            <a:avLst/>
+          </a:prstGeom>
+          <a:noFill/>
+        </p:spPr>
+        <p:txBody>
           <a:bodyPr wrap="square" anchor="ctr" lIns="0" rIns="0" tIns="0" bIns="0">
             <a:spAutoFit/>
           </a:bodyPr>
@@ -4375,230 +3342,23 @@
           <a:p>
             <a:pPr algn="l">
               <a:lnSpc>
-                <a:spcPct val="116000"/>
+                <a:spcPct val="100000"/>
               </a:lnSpc>
               <a:spcAft>
-                <a:spcPts val="1700"/>
+                <a:spcPts val="0"/>
               </a:spcAft>
             </a:pPr>
             <a:r>
-              <a:rPr sz="950" b="0">
-                <a:solidFill>
-                  <a:srgbClr val="EC856F"/>
-                </a:solidFill>
-                <a:latin typeface="游ゴシック"/>
-                <a:ea typeface="游ゴシック"/>
-                <a:cs typeface="游ゴシック"/>
-              </a:rPr>
-              <a:t>● </a:t>
-            </a:r>
-            <a:r>
-              <a:rPr sz="1300" b="0">
-                <a:solidFill>
-                  <a:srgbClr val="232323"/>
-                </a:solidFill>
-                <a:latin typeface="游ゴシック"/>
-                <a:ea typeface="游ゴシック"/>
-                <a:cs typeface="游ゴシック"/>
-              </a:rPr>
-              <a:t>全11チームが順に報告</a:t>
-            </a:r>
-          </a:p>
-          <a:p>
-            <a:pPr algn="l">
-              <a:lnSpc>
-                <a:spcPct val="116000"/>
-              </a:lnSpc>
-              <a:spcAft>
-                <a:spcPts val="1700"/>
-              </a:spcAft>
-            </a:pPr>
-            <a:r>
-              <a:rPr sz="950" b="0">
-                <a:solidFill>
-                  <a:srgbClr val="EC856F"/>
-                </a:solidFill>
-                <a:latin typeface="游ゴシック"/>
-                <a:ea typeface="游ゴシック"/>
-                <a:cs typeface="游ゴシック"/>
-              </a:rPr>
-              <a:t>● </a:t>
-            </a:r>
-            <a:r>
-              <a:rPr sz="1300" b="0">
-                <a:solidFill>
-                  <a:srgbClr val="232323"/>
-                </a:solidFill>
-                <a:latin typeface="游ゴシック"/>
-                <a:ea typeface="游ゴシック"/>
-                <a:cs typeface="游ゴシック"/>
-              </a:rPr>
-              <a:t>持ち時間 各10分（質疑含む）</a:t>
-            </a:r>
-          </a:p>
-          <a:p>
-            <a:pPr algn="l">
-              <a:lnSpc>
-                <a:spcPct val="116000"/>
-              </a:lnSpc>
-              <a:spcAft>
-                <a:spcPts val="1700"/>
-              </a:spcAft>
-            </a:pPr>
-            <a:r>
-              <a:rPr sz="950" b="0">
-                <a:solidFill>
-                  <a:srgbClr val="EC856F"/>
-                </a:solidFill>
-                <a:latin typeface="游ゴシック"/>
-                <a:ea typeface="游ゴシック"/>
-                <a:cs typeface="游ゴシック"/>
-              </a:rPr>
-              <a:t>● </a:t>
-            </a:r>
-            <a:r>
-              <a:rPr sz="1300" b="1">
-                <a:solidFill>
-                  <a:srgbClr val="EC856F"/>
-                </a:solidFill>
-                <a:latin typeface="游ゴシック"/>
-                <a:ea typeface="游ゴシック"/>
-                <a:cs typeface="游ゴシック"/>
-              </a:rPr>
-              <a:t>発表は5〜7分程度</a:t>
-            </a:r>
-          </a:p>
-        </p:txBody>
-      </p:sp>
-      <p:sp>
-        <p:nvSpPr>
-          <p:cNvPr id="23" name="Chevron 22"/>
-          <p:cNvSpPr/>
-          <p:nvPr/>
-        </p:nvSpPr>
-        <p:spPr>
-          <a:xfrm>
-            <a:off x="3637275" y="3880000"/>
-            <a:ext cx="150000" cy="180000"/>
-          </a:xfrm>
-          <a:prstGeom prst="chevron">
-            <a:avLst/>
-          </a:prstGeom>
-          <a:solidFill>
-            <a:srgbClr val="BBC7CC"/>
-          </a:solidFill>
-          <a:ln>
-            <a:noFill/>
-          </a:ln>
-          <a:effectLst/>
-        </p:spPr>
-        <p:style>
-          <a:lnRef idx="1">
-            <a:schemeClr val="accent1"/>
-          </a:lnRef>
-          <a:fillRef idx="3">
-            <a:schemeClr val="accent1"/>
-          </a:fillRef>
-          <a:effectRef idx="2">
-            <a:schemeClr val="accent1"/>
-          </a:effectRef>
-          <a:fontRef idx="minor">
-            <a:schemeClr val="lt1"/>
-          </a:fontRef>
-        </p:style>
-        <p:txBody>
-          <a:bodyPr rtlCol="0" anchor="ctr"/>
-          <a:lstStyle/>
-          <a:p>
-            <a:pPr algn="ctr"/>
-          </a:p>
-        </p:txBody>
-      </p:sp>
-      <p:sp>
-        <p:nvSpPr>
-          <p:cNvPr id="24" name="Chevron 23"/>
-          <p:cNvSpPr/>
-          <p:nvPr/>
-        </p:nvSpPr>
-        <p:spPr>
-          <a:xfrm>
-            <a:off x="6645004" y="3880000"/>
-            <a:ext cx="150000" cy="180000"/>
-          </a:xfrm>
-          <a:prstGeom prst="chevron">
-            <a:avLst/>
-          </a:prstGeom>
-          <a:solidFill>
-            <a:srgbClr val="BBC7CC"/>
-          </a:solidFill>
-          <a:ln>
-            <a:noFill/>
-          </a:ln>
-          <a:effectLst/>
-        </p:spPr>
-        <p:style>
-          <a:lnRef idx="1">
-            <a:schemeClr val="accent1"/>
-          </a:lnRef>
-          <a:fillRef idx="3">
-            <a:schemeClr val="accent1"/>
-          </a:fillRef>
-          <a:effectRef idx="2">
-            <a:schemeClr val="accent1"/>
-          </a:effectRef>
-          <a:fontRef idx="minor">
-            <a:schemeClr val="lt1"/>
-          </a:fontRef>
-        </p:style>
-        <p:txBody>
-          <a:bodyPr rtlCol="0" anchor="ctr"/>
-          <a:lstStyle/>
-          <a:p>
-            <a:pPr algn="ctr"/>
-          </a:p>
-        </p:txBody>
-      </p:sp>
-      <p:sp>
-        <p:nvSpPr>
-          <p:cNvPr id="25" name="Chevron 24"/>
-          <p:cNvSpPr/>
-          <p:nvPr/>
-        </p:nvSpPr>
-        <p:spPr>
-          <a:xfrm>
-            <a:off x="9652733" y="3880000"/>
-            <a:ext cx="150000" cy="180000"/>
-          </a:xfrm>
-          <a:prstGeom prst="chevron">
-            <a:avLst/>
-          </a:prstGeom>
-          <a:solidFill>
-            <a:srgbClr val="BBC7CC"/>
-          </a:solidFill>
-          <a:ln>
-            <a:noFill/>
-          </a:ln>
-          <a:effectLst/>
-        </p:spPr>
-        <p:style>
-          <a:lnRef idx="1">
-            <a:schemeClr val="accent1"/>
-          </a:lnRef>
-          <a:fillRef idx="3">
-            <a:schemeClr val="accent1"/>
-          </a:fillRef>
-          <a:effectRef idx="2">
-            <a:schemeClr val="accent1"/>
-          </a:effectRef>
-          <a:fontRef idx="minor">
-            <a:schemeClr val="lt1"/>
-          </a:fontRef>
-        </p:style>
-        <p:txBody>
-          <a:bodyPr rtlCol="0" anchor="ctr"/>
-          <a:lstStyle/>
-          <a:p>
-            <a:pPr algn="ctr"/>
+              <a:rPr sz="900" b="0">
+                <a:solidFill>
+                  <a:srgbClr val="AEB8BD"/>
+                </a:solidFill>
+                <a:latin typeface="游ゴシック"/>
+                <a:ea typeface="游ゴシック"/>
+                <a:cs typeface="游ゴシック"/>
+              </a:rPr>
+              <a:t>© 2026 Low Code Inc. All rights reserved.</a:t>
+            </a:r>
           </a:p>
         </p:txBody>
       </p:sp>
@@ -4628,8 +3388,8 @@
         </p:nvSpPr>
         <p:spPr>
           <a:xfrm>
-            <a:off x="814546" y="360000"/>
-            <a:ext cx="11810918" cy="470000"/>
+            <a:off x="814546" y="350000"/>
+            <a:ext cx="11810918" cy="480000"/>
           </a:xfrm>
           <a:prstGeom prst="rect">
             <a:avLst/>
@@ -4659,7 +3419,7 @@
                 <a:ea typeface="游ゴシック"/>
                 <a:cs typeface="游ゴシック"/>
               </a:rPr>
-              <a:t>本日のポイント ｜ 事前相談会②</a:t>
+              <a:t>事前相談会②　本日のポイント</a:t>
             </a:r>
           </a:p>
         </p:txBody>
@@ -4672,8 +3432,8 @@
         </p:nvSpPr>
         <p:spPr>
           <a:xfrm>
-            <a:off x="797689" y="809974"/>
-            <a:ext cx="11827398" cy="89379"/>
+            <a:off x="797689" y="820000"/>
+            <a:ext cx="11827398" cy="82000"/>
           </a:xfrm>
           <a:prstGeom prst="rect">
             <a:avLst/>
@@ -4760,7 +3520,7 @@
         </p:nvSpPr>
         <p:spPr>
           <a:xfrm>
-            <a:off x="12650000" y="7057560"/>
+            <a:off x="12650000" y="7060000"/>
             <a:ext cx="543031" cy="360000"/>
           </a:xfrm>
           <a:prstGeom prst="rect">
@@ -4804,102 +3564,12 @@
         </p:nvSpPr>
         <p:spPr>
           <a:xfrm>
-            <a:off x="814546" y="1010000"/>
-            <a:ext cx="300000" cy="300000"/>
+            <a:off x="814546" y="1120000"/>
+            <a:ext cx="5715459" cy="4650000"/>
           </a:xfrm>
           <a:prstGeom prst="roundRect">
             <a:avLst>
-              <a:gd name="adj" fmla="val 28000"/>
-            </a:avLst>
-          </a:prstGeom>
-          <a:solidFill>
-            <a:srgbClr val="EC856F"/>
-          </a:solidFill>
-          <a:ln>
-            <a:noFill/>
-          </a:ln>
-          <a:effectLst/>
-        </p:spPr>
-        <p:style>
-          <a:lnRef idx="1">
-            <a:schemeClr val="accent1"/>
-          </a:lnRef>
-          <a:fillRef idx="3">
-            <a:schemeClr val="accent1"/>
-          </a:fillRef>
-          <a:effectRef idx="2">
-            <a:schemeClr val="accent1"/>
-          </a:effectRef>
-          <a:fontRef idx="minor">
-            <a:schemeClr val="lt1"/>
-          </a:fontRef>
-        </p:style>
-        <p:txBody>
-          <a:bodyPr rtlCol="0" anchor="ctr" wrap="square"/>
-          <a:lstStyle/>
-          <a:p>
-            <a:pPr algn="ctr"/>
-          </a:p>
-        </p:txBody>
-      </p:sp>
-      <p:sp>
-        <p:nvSpPr>
-          <p:cNvPr id="7" name="TextBox 6"/>
-          <p:cNvSpPr txBox="1"/>
-          <p:nvPr/>
-        </p:nvSpPr>
-        <p:spPr>
-          <a:xfrm>
-            <a:off x="1264546" y="970000"/>
-            <a:ext cx="11360918" cy="420000"/>
-          </a:xfrm>
-          <a:prstGeom prst="rect">
-            <a:avLst/>
-          </a:prstGeom>
-          <a:noFill/>
-        </p:spPr>
-        <p:txBody>
-          <a:bodyPr wrap="square" anchor="ctr" lIns="0" rIns="0" tIns="0" bIns="0">
-            <a:spAutoFit/>
-          </a:bodyPr>
-          <a:lstStyle/>
-          <a:p>
-            <a:pPr algn="l">
-              <a:lnSpc>
-                <a:spcPct val="100000"/>
-              </a:lnSpc>
-              <a:spcAft>
-                <a:spcPts val="0"/>
-              </a:spcAft>
-            </a:pPr>
-            <a:r>
-              <a:rPr sz="1650" b="1">
-                <a:solidFill>
-                  <a:srgbClr val="232323"/>
-                </a:solidFill>
-                <a:latin typeface="游ゴシック"/>
-                <a:ea typeface="游ゴシック"/>
-                <a:cs typeface="游ゴシック"/>
-              </a:rPr>
-              <a:t>本日ご相談いただきたいこと</a:t>
-            </a:r>
-          </a:p>
-        </p:txBody>
-      </p:sp>
-      <p:sp>
-        <p:nvSpPr>
-          <p:cNvPr id="8" name="Rounded Rectangle 7"/>
-          <p:cNvSpPr/>
-          <p:nvPr/>
-        </p:nvSpPr>
-        <p:spPr>
-          <a:xfrm>
-            <a:off x="814546" y="1520000"/>
-            <a:ext cx="5755459" cy="1360000"/>
-          </a:xfrm>
-          <a:prstGeom prst="roundRect">
-            <a:avLst>
-              <a:gd name="adj" fmla="val 7000"/>
+              <a:gd name="adj" fmla="val 4500"/>
             </a:avLst>
           </a:prstGeom>
           <a:solidFill>
@@ -4914,7 +3584,7 @@
           <a:effectLst>
             <a:outerShdw blurRad="50800" dist="25400" dir="5400000" rotWithShape="0">
               <a:srgbClr val="8AA6B0">
-                <a:alpha val="38000"/>
+                <a:alpha val="36000"/>
               </a:srgbClr>
             </a:outerShdw>
           </a:effectLst>
@@ -4943,14 +3613,14 @@
       </p:sp>
       <p:sp>
         <p:nvSpPr>
-          <p:cNvPr id="9" name="Oval 8"/>
+          <p:cNvPr id="7" name="Oval 6"/>
           <p:cNvSpPr/>
           <p:nvPr/>
         </p:nvSpPr>
         <p:spPr>
           <a:xfrm>
-            <a:off x="1014546" y="1720000"/>
-            <a:ext cx="430000" cy="430000"/>
+            <a:off x="1134546" y="1460000"/>
+            <a:ext cx="560000" cy="560000"/>
           </a:xfrm>
           <a:prstGeom prst="ellipse">
             <a:avLst/>
@@ -4983,7 +3653,7 @@
           <a:p>
             <a:pPr algn="ctr"/>
             <a:r>
-              <a:rPr sz="1700" b="1">
+              <a:rPr sz="2400" b="1">
                 <a:solidFill>
                   <a:srgbClr val="FFFFFF"/>
                 </a:solidFill>
@@ -4991,21 +3661,21 @@
                 <a:ea typeface="游ゴシック"/>
                 <a:cs typeface="游ゴシック"/>
               </a:rPr>
-              <a:t>1</a:t>
-            </a:r>
-          </a:p>
-        </p:txBody>
-      </p:sp>
-      <p:sp>
-        <p:nvSpPr>
-          <p:cNvPr id="10" name="TextBox 9"/>
+              <a:t>✓</a:t>
+            </a:r>
+          </a:p>
+        </p:txBody>
+      </p:sp>
+      <p:sp>
+        <p:nvSpPr>
+          <p:cNvPr id="8" name="TextBox 7"/>
           <p:cNvSpPr txBox="1"/>
           <p:nvPr/>
         </p:nvSpPr>
         <p:spPr>
           <a:xfrm>
-            <a:off x="1574546" y="1740000"/>
-            <a:ext cx="4815459" cy="400000"/>
+            <a:off x="1864546" y="1480000"/>
+            <a:ext cx="4495459" cy="520000"/>
           </a:xfrm>
           <a:prstGeom prst="rect">
             <a:avLst/>
@@ -5027,29 +3697,29 @@
               </a:spcAft>
             </a:pPr>
             <a:r>
-              <a:rPr sz="1600" b="1">
-                <a:solidFill>
-                  <a:srgbClr val="1B5C80"/>
-                </a:solidFill>
-                <a:latin typeface="游ゴシック"/>
-                <a:ea typeface="游ゴシック"/>
-                <a:cs typeface="游ゴシック"/>
-              </a:rPr>
-              <a:t>企画の実現性</a:t>
-            </a:r>
-          </a:p>
-        </p:txBody>
-      </p:sp>
-      <p:sp>
-        <p:nvSpPr>
-          <p:cNvPr id="11" name="TextBox 10"/>
+              <a:rPr sz="1900" b="1">
+                <a:solidFill>
+                  <a:srgbClr val="0FA4CC"/>
+                </a:solidFill>
+                <a:latin typeface="游ゴシック"/>
+                <a:ea typeface="游ゴシック"/>
+                <a:cs typeface="游ゴシック"/>
+              </a:rPr>
+              <a:t>本日の目的</a:t>
+            </a:r>
+          </a:p>
+        </p:txBody>
+      </p:sp>
+      <p:sp>
+        <p:nvSpPr>
+          <p:cNvPr id="9" name="TextBox 8"/>
           <p:cNvSpPr txBox="1"/>
           <p:nvPr/>
         </p:nvSpPr>
         <p:spPr>
           <a:xfrm>
-            <a:off x="1034546" y="2240000"/>
-            <a:ext cx="5315459" cy="540000"/>
+            <a:off x="1134546" y="2300000"/>
+            <a:ext cx="5075459" cy="3200000"/>
           </a:xfrm>
           <a:prstGeom prst="rect">
             <a:avLst/>
@@ -5057,21 +3727,401 @@
           <a:noFill/>
         </p:spPr>
         <p:txBody>
-          <a:bodyPr wrap="square" anchor="t" lIns="0" rIns="0" tIns="0" bIns="0">
+          <a:bodyPr wrap="square" anchor="ctr" lIns="0" rIns="0" tIns="0" bIns="0">
             <a:spAutoFit/>
           </a:bodyPr>
           <a:lstStyle/>
           <a:p>
             <a:pPr algn="l">
               <a:lnSpc>
-                <a:spcPct val="120000"/>
+                <a:spcPct val="115000"/>
+              </a:lnSpc>
+              <a:spcAft>
+                <a:spcPts val="300"/>
+              </a:spcAft>
+            </a:pPr>
+            <a:r>
+              <a:rPr sz="1200" b="0">
+                <a:solidFill>
+                  <a:srgbClr val="0FA4CC"/>
+                </a:solidFill>
+                <a:latin typeface="游ゴシック"/>
+                <a:ea typeface="游ゴシック"/>
+                <a:cs typeface="游ゴシック"/>
+              </a:rPr>
+              <a:t>●  </a:t>
+            </a:r>
+            <a:r>
+              <a:rPr sz="1500" b="1">
+                <a:solidFill>
+                  <a:srgbClr val="232323"/>
+                </a:solidFill>
+                <a:latin typeface="游ゴシック"/>
+                <a:ea typeface="游ゴシック"/>
+                <a:cs typeface="游ゴシック"/>
+              </a:rPr>
+              <a:t>企画内容の実現可能性を確認</a:t>
+            </a:r>
+          </a:p>
+          <a:p>
+            <a:pPr algn="l">
+              <a:lnSpc>
+                <a:spcPct val="115000"/>
+              </a:lnSpc>
+              <a:spcAft>
+                <a:spcPts val="2000"/>
+              </a:spcAft>
+            </a:pPr>
+            <a:r>
+              <a:rPr sz="1100" b="0">
+                <a:solidFill>
+                  <a:srgbClr val="5A6E77"/>
+                </a:solidFill>
+                <a:latin typeface="游ゴシック"/>
+                <a:ea typeface="游ゴシック"/>
+                <a:cs typeface="游ゴシック"/>
+              </a:rPr>
+              <a:t>　　</a:t>
+            </a:r>
+            <a:r>
+              <a:rPr sz="1150" b="0">
+                <a:solidFill>
+                  <a:srgbClr val="5A6E77"/>
+                </a:solidFill>
+                <a:latin typeface="游ゴシック"/>
+                <a:ea typeface="游ゴシック"/>
+                <a:cs typeface="游ゴシック"/>
+              </a:rPr>
+              <a:t>「M365内で実現できるか」を一緒に確認します</a:t>
+            </a:r>
+          </a:p>
+          <a:p>
+            <a:pPr algn="l">
+              <a:lnSpc>
+                <a:spcPct val="115000"/>
+              </a:lnSpc>
+              <a:spcAft>
+                <a:spcPts val="300"/>
+              </a:spcAft>
+            </a:pPr>
+            <a:r>
+              <a:rPr sz="1200" b="0">
+                <a:solidFill>
+                  <a:srgbClr val="0FA4CC"/>
+                </a:solidFill>
+                <a:latin typeface="游ゴシック"/>
+                <a:ea typeface="游ゴシック"/>
+                <a:cs typeface="游ゴシック"/>
+              </a:rPr>
+              <a:t>●  </a:t>
+            </a:r>
+            <a:r>
+              <a:rPr sz="1500" b="1">
+                <a:solidFill>
+                  <a:srgbClr val="232323"/>
+                </a:solidFill>
+                <a:latin typeface="游ゴシック"/>
+                <a:ea typeface="游ゴシック"/>
+                <a:cs typeface="游ゴシック"/>
+              </a:rPr>
+              <a:t>技術課題に対するアドバイス</a:t>
+            </a:r>
+          </a:p>
+          <a:p>
+            <a:pPr algn="l">
+              <a:lnSpc>
+                <a:spcPct val="115000"/>
+              </a:lnSpc>
+              <a:spcAft>
+                <a:spcPts val="2000"/>
+              </a:spcAft>
+            </a:pPr>
+            <a:r>
+              <a:rPr sz="1100" b="0">
+                <a:solidFill>
+                  <a:srgbClr val="5A6E77"/>
+                </a:solidFill>
+                <a:latin typeface="游ゴシック"/>
+                <a:ea typeface="游ゴシック"/>
+                <a:cs typeface="游ゴシック"/>
+              </a:rPr>
+              <a:t>　　</a:t>
+            </a:r>
+            <a:r>
+              <a:rPr sz="1150" b="0">
+                <a:solidFill>
+                  <a:srgbClr val="5A6E77"/>
+                </a:solidFill>
+                <a:latin typeface="游ゴシック"/>
+                <a:ea typeface="游ゴシック"/>
+                <a:cs typeface="游ゴシック"/>
+              </a:rPr>
+              <a:t>つまずいている技術的な点の解消をお手伝いします</a:t>
+            </a:r>
+          </a:p>
+          <a:p>
+            <a:pPr algn="l">
+              <a:lnSpc>
+                <a:spcPct val="115000"/>
+              </a:lnSpc>
+              <a:spcAft>
+                <a:spcPts val="300"/>
+              </a:spcAft>
+            </a:pPr>
+            <a:r>
+              <a:rPr sz="1200" b="0">
+                <a:solidFill>
+                  <a:srgbClr val="0FA4CC"/>
+                </a:solidFill>
+                <a:latin typeface="游ゴシック"/>
+                <a:ea typeface="游ゴシック"/>
+                <a:cs typeface="游ゴシック"/>
+              </a:rPr>
+              <a:t>●  </a:t>
+            </a:r>
+            <a:r>
+              <a:rPr sz="1500" b="1">
+                <a:solidFill>
+                  <a:srgbClr val="232323"/>
+                </a:solidFill>
+                <a:latin typeface="游ゴシック"/>
+                <a:ea typeface="游ゴシック"/>
+                <a:cs typeface="游ゴシック"/>
+              </a:rPr>
+              <a:t>質疑応答・懸念事項の相談</a:t>
+            </a:r>
+          </a:p>
+          <a:p>
+            <a:pPr algn="l">
+              <a:lnSpc>
+                <a:spcPct val="115000"/>
+              </a:lnSpc>
+              <a:spcAft>
+                <a:spcPts val="2000"/>
+              </a:spcAft>
+            </a:pPr>
+            <a:r>
+              <a:rPr sz="1100" b="0">
+                <a:solidFill>
+                  <a:srgbClr val="5A6E77"/>
+                </a:solidFill>
+                <a:latin typeface="游ゴシック"/>
+                <a:ea typeface="游ゴシック"/>
+                <a:cs typeface="游ゴシック"/>
+              </a:rPr>
+              <a:t>　　</a:t>
+            </a:r>
+            <a:r>
+              <a:rPr sz="1150" b="0">
+                <a:solidFill>
+                  <a:srgbClr val="5A6E77"/>
+                </a:solidFill>
+                <a:latin typeface="游ゴシック"/>
+                <a:ea typeface="游ゴシック"/>
+                <a:cs typeface="游ゴシック"/>
+              </a:rPr>
+              <a:t>気になる点・不安な点は何でもご相談ください</a:t>
+            </a:r>
+          </a:p>
+        </p:txBody>
+      </p:sp>
+      <p:sp>
+        <p:nvSpPr>
+          <p:cNvPr id="10" name="Rounded Rectangle 9"/>
+          <p:cNvSpPr/>
+          <p:nvPr/>
+        </p:nvSpPr>
+        <p:spPr>
+          <a:xfrm>
+            <a:off x="6910005" y="1120000"/>
+            <a:ext cx="5715459" cy="4650000"/>
+          </a:xfrm>
+          <a:prstGeom prst="roundRect">
+            <a:avLst>
+              <a:gd name="adj" fmla="val 4500"/>
+            </a:avLst>
+          </a:prstGeom>
+          <a:solidFill>
+            <a:srgbClr val="FCEEE9"/>
+          </a:solidFill>
+          <a:ln w="9525">
+            <a:solidFill>
+              <a:srgbClr val="F0B7A8"/>
+            </a:solidFill>
+          </a:ln>
+          <a:effectLst/>
+          <a:effectLst>
+            <a:outerShdw blurRad="50800" dist="25400" dir="5400000" rotWithShape="0">
+              <a:srgbClr val="8AA6B0">
+                <a:alpha val="36000"/>
+              </a:srgbClr>
+            </a:outerShdw>
+          </a:effectLst>
+        </p:spPr>
+        <p:style>
+          <a:lnRef idx="1">
+            <a:schemeClr val="accent1"/>
+          </a:lnRef>
+          <a:fillRef idx="3">
+            <a:schemeClr val="accent1"/>
+          </a:fillRef>
+          <a:effectRef idx="2">
+            <a:schemeClr val="accent1"/>
+          </a:effectRef>
+          <a:fontRef idx="minor">
+            <a:schemeClr val="lt1"/>
+          </a:fontRef>
+        </p:style>
+        <p:txBody>
+          <a:bodyPr rtlCol="0" anchor="ctr" wrap="square"/>
+          <a:lstStyle/>
+          <a:p>
+            <a:pPr algn="ctr"/>
+          </a:p>
+        </p:txBody>
+      </p:sp>
+      <p:sp>
+        <p:nvSpPr>
+          <p:cNvPr id="11" name="Oval 10"/>
+          <p:cNvSpPr/>
+          <p:nvPr/>
+        </p:nvSpPr>
+        <p:spPr>
+          <a:xfrm>
+            <a:off x="7230005" y="1460000"/>
+            <a:ext cx="560000" cy="560000"/>
+          </a:xfrm>
+          <a:prstGeom prst="ellipse">
+            <a:avLst/>
+          </a:prstGeom>
+          <a:solidFill>
+            <a:srgbClr val="EC856F"/>
+          </a:solidFill>
+          <a:ln>
+            <a:noFill/>
+          </a:ln>
+          <a:effectLst/>
+        </p:spPr>
+        <p:style>
+          <a:lnRef idx="1">
+            <a:schemeClr val="accent1"/>
+          </a:lnRef>
+          <a:fillRef idx="3">
+            <a:schemeClr val="accent1"/>
+          </a:fillRef>
+          <a:effectRef idx="2">
+            <a:schemeClr val="accent1"/>
+          </a:effectRef>
+          <a:fontRef idx="minor">
+            <a:schemeClr val="lt1"/>
+          </a:fontRef>
+        </p:style>
+        <p:txBody>
+          <a:bodyPr rtlCol="0" anchor="ctr" lIns="0" rIns="0" tIns="0" bIns="0" wrap="none"/>
+          <a:lstStyle/>
+          <a:p>
+            <a:pPr algn="ctr"/>
+            <a:r>
+              <a:rPr sz="2400" b="1">
+                <a:solidFill>
+                  <a:srgbClr val="FFFFFF"/>
+                </a:solidFill>
+                <a:latin typeface="游ゴシック"/>
+                <a:ea typeface="游ゴシック"/>
+                <a:cs typeface="游ゴシック"/>
+              </a:rPr>
+              <a:t>!</a:t>
+            </a:r>
+          </a:p>
+        </p:txBody>
+      </p:sp>
+      <p:sp>
+        <p:nvSpPr>
+          <p:cNvPr id="12" name="TextBox 11"/>
+          <p:cNvSpPr txBox="1"/>
+          <p:nvPr/>
+        </p:nvSpPr>
+        <p:spPr>
+          <a:xfrm>
+            <a:off x="7960005" y="1480000"/>
+            <a:ext cx="4495459" cy="520000"/>
+          </a:xfrm>
+          <a:prstGeom prst="rect">
+            <a:avLst/>
+          </a:prstGeom>
+          <a:noFill/>
+        </p:spPr>
+        <p:txBody>
+          <a:bodyPr wrap="square" anchor="ctr" lIns="0" rIns="0" tIns="0" bIns="0">
+            <a:spAutoFit/>
+          </a:bodyPr>
+          <a:lstStyle/>
+          <a:p>
+            <a:pPr algn="l">
+              <a:lnSpc>
+                <a:spcPct val="100000"/>
               </a:lnSpc>
               <a:spcAft>
                 <a:spcPts val="0"/>
               </a:spcAft>
             </a:pPr>
             <a:r>
-              <a:rPr sz="1300" b="0">
+              <a:rPr sz="1900" b="1">
+                <a:solidFill>
+                  <a:srgbClr val="EC856F"/>
+                </a:solidFill>
+                <a:latin typeface="游ゴシック"/>
+                <a:ea typeface="游ゴシック"/>
+                <a:cs typeface="游ゴシック"/>
+              </a:rPr>
+              <a:t>ガイドライン準拠の確認</a:t>
+            </a:r>
+          </a:p>
+        </p:txBody>
+      </p:sp>
+      <p:sp>
+        <p:nvSpPr>
+          <p:cNvPr id="13" name="TextBox 12"/>
+          <p:cNvSpPr txBox="1"/>
+          <p:nvPr/>
+        </p:nvSpPr>
+        <p:spPr>
+          <a:xfrm>
+            <a:off x="7230005" y="2300000"/>
+            <a:ext cx="5075459" cy="3200000"/>
+          </a:xfrm>
+          <a:prstGeom prst="rect">
+            <a:avLst/>
+          </a:prstGeom>
+          <a:noFill/>
+        </p:spPr>
+        <p:txBody>
+          <a:bodyPr wrap="square" anchor="ctr" lIns="0" rIns="0" tIns="0" bIns="0">
+            <a:spAutoFit/>
+          </a:bodyPr>
+          <a:lstStyle/>
+          <a:p>
+            <a:pPr algn="l">
+              <a:lnSpc>
+                <a:spcPct val="115000"/>
+              </a:lnSpc>
+              <a:spcAft>
+                <a:spcPts val="300"/>
+              </a:spcAft>
+            </a:pPr>
+            <a:r>
+              <a:rPr sz="1200" b="0">
+                <a:solidFill>
+                  <a:srgbClr val="EC856F"/>
+                </a:solidFill>
+                <a:latin typeface="游ゴシック"/>
+                <a:ea typeface="游ゴシック"/>
+                <a:cs typeface="游ゴシック"/>
+              </a:rPr>
+              <a:t>●  </a:t>
+            </a:r>
+            <a:r>
+              <a:rPr sz="1500" b="1">
                 <a:solidFill>
                   <a:srgbClr val="232323"/>
                 </a:solidFill>
@@ -5079,25 +4129,988 @@
                 <a:ea typeface="游ゴシック"/>
                 <a:cs typeface="游ゴシック"/>
               </a:rPr>
-              <a:t>企画が実現可能かどうかを一緒に確認し、アドバイスします。</a:t>
-            </a:r>
-          </a:p>
-        </p:txBody>
-      </p:sp>
-      <p:sp>
-        <p:nvSpPr>
-          <p:cNvPr id="12" name="Rounded Rectangle 11"/>
+              <a:t>M365外のシステム連携は不可</a:t>
+            </a:r>
+          </a:p>
+          <a:p>
+            <a:pPr algn="l">
+              <a:lnSpc>
+                <a:spcPct val="115000"/>
+              </a:lnSpc>
+              <a:spcAft>
+                <a:spcPts val="2000"/>
+              </a:spcAft>
+            </a:pPr>
+            <a:r>
+              <a:rPr sz="1100" b="0">
+                <a:solidFill>
+                  <a:srgbClr val="5A6E77"/>
+                </a:solidFill>
+                <a:latin typeface="游ゴシック"/>
+                <a:ea typeface="游ゴシック"/>
+                <a:cs typeface="游ゴシック"/>
+              </a:rPr>
+              <a:t>　　</a:t>
+            </a:r>
+            <a:r>
+              <a:rPr sz="1150" b="0">
+                <a:solidFill>
+                  <a:srgbClr val="5A6E77"/>
+                </a:solidFill>
+                <a:latin typeface="游ゴシック"/>
+                <a:ea typeface="游ゴシック"/>
+                <a:cs typeface="游ゴシック"/>
+              </a:rPr>
+              <a:t>Salesforce など外部システムへの接続はNG</a:t>
+            </a:r>
+          </a:p>
+          <a:p>
+            <a:pPr algn="l">
+              <a:lnSpc>
+                <a:spcPct val="115000"/>
+              </a:lnSpc>
+              <a:spcAft>
+                <a:spcPts val="300"/>
+              </a:spcAft>
+            </a:pPr>
+            <a:r>
+              <a:rPr sz="1200" b="0">
+                <a:solidFill>
+                  <a:srgbClr val="EC856F"/>
+                </a:solidFill>
+                <a:latin typeface="游ゴシック"/>
+                <a:ea typeface="游ゴシック"/>
+                <a:cs typeface="游ゴシック"/>
+              </a:rPr>
+              <a:t>●  </a:t>
+            </a:r>
+            <a:r>
+              <a:rPr sz="1500" b="1">
+                <a:solidFill>
+                  <a:srgbClr val="232323"/>
+                </a:solidFill>
+                <a:latin typeface="游ゴシック"/>
+                <a:ea typeface="游ゴシック"/>
+                <a:cs typeface="游ゴシック"/>
+              </a:rPr>
+              <a:t>個人情報・極秘情報を含めない</a:t>
+            </a:r>
+          </a:p>
+          <a:p>
+            <a:pPr algn="l">
+              <a:lnSpc>
+                <a:spcPct val="115000"/>
+              </a:lnSpc>
+              <a:spcAft>
+                <a:spcPts val="2000"/>
+              </a:spcAft>
+            </a:pPr>
+            <a:r>
+              <a:rPr sz="1100" b="0">
+                <a:solidFill>
+                  <a:srgbClr val="5A6E77"/>
+                </a:solidFill>
+                <a:latin typeface="游ゴシック"/>
+                <a:ea typeface="游ゴシック"/>
+                <a:cs typeface="游ゴシック"/>
+              </a:rPr>
+              <a:t>　　</a:t>
+            </a:r>
+            <a:r>
+              <a:rPr sz="1150" b="0">
+                <a:solidFill>
+                  <a:srgbClr val="5A6E77"/>
+                </a:solidFill>
+                <a:latin typeface="游ゴシック"/>
+                <a:ea typeface="游ゴシック"/>
+                <a:cs typeface="游ゴシック"/>
+              </a:rPr>
+              <a:t>読み込み先に機微な情報が入らないようにする</a:t>
+            </a:r>
+          </a:p>
+          <a:p>
+            <a:pPr algn="l">
+              <a:lnSpc>
+                <a:spcPct val="115000"/>
+              </a:lnSpc>
+              <a:spcAft>
+                <a:spcPts val="300"/>
+              </a:spcAft>
+            </a:pPr>
+            <a:r>
+              <a:rPr sz="1200" b="0">
+                <a:solidFill>
+                  <a:srgbClr val="EC856F"/>
+                </a:solidFill>
+                <a:latin typeface="游ゴシック"/>
+                <a:ea typeface="游ゴシック"/>
+                <a:cs typeface="游ゴシック"/>
+              </a:rPr>
+              <a:t>●  </a:t>
+            </a:r>
+            <a:r>
+              <a:rPr sz="1500" b="1">
+                <a:solidFill>
+                  <a:srgbClr val="232323"/>
+                </a:solidFill>
+                <a:latin typeface="游ゴシック"/>
+                <a:ea typeface="游ゴシック"/>
+                <a:cs typeface="游ゴシック"/>
+              </a:rPr>
+              <a:t>外部サイトの情報取得はしない</a:t>
+            </a:r>
+          </a:p>
+          <a:p>
+            <a:pPr algn="l">
+              <a:lnSpc>
+                <a:spcPct val="115000"/>
+              </a:lnSpc>
+              <a:spcAft>
+                <a:spcPts val="2000"/>
+              </a:spcAft>
+            </a:pPr>
+            <a:r>
+              <a:rPr sz="1100" b="0">
+                <a:solidFill>
+                  <a:srgbClr val="5A6E77"/>
+                </a:solidFill>
+                <a:latin typeface="游ゴシック"/>
+                <a:ea typeface="游ゴシック"/>
+                <a:cs typeface="游ゴシック"/>
+              </a:rPr>
+              <a:t>　　</a:t>
+            </a:r>
+            <a:r>
+              <a:rPr sz="1150" b="0">
+                <a:solidFill>
+                  <a:srgbClr val="5A6E77"/>
+                </a:solidFill>
+                <a:latin typeface="游ゴシック"/>
+                <a:ea typeface="游ゴシック"/>
+                <a:cs typeface="游ゴシック"/>
+              </a:rPr>
+              <a:t>例：特定企業HPからのIR情報取得など（スクレイピング）</a:t>
+            </a:r>
+          </a:p>
+        </p:txBody>
+      </p:sp>
+    </p:spTree>
+  </p:cSld>
+  <p:clrMapOvr>
+    <a:masterClrMapping/>
+  </p:clrMapOvr>
+</p:sld>
+</file>
+
+<file path=ppt/slides/slide3.xml><?xml version="1.0" encoding="utf-8"?>
+<p:sld xmlns:a="http://schemas.openxmlformats.org/drawingml/2006/main" xmlns:p="http://schemas.openxmlformats.org/presentationml/2006/main" xmlns:r="http://schemas.openxmlformats.org/officeDocument/2006/relationships">
+  <p:cSld>
+    <p:spTree>
+      <p:nvGrpSpPr>
+        <p:cNvPr id="1" name=""/>
+        <p:cNvGrpSpPr/>
+        <p:nvPr/>
+      </p:nvGrpSpPr>
+      <p:grpSpPr/>
+      <p:sp>
+        <p:nvSpPr>
+          <p:cNvPr id="2" name="TextBox 1"/>
+          <p:cNvSpPr txBox="1"/>
+          <p:nvPr/>
+        </p:nvSpPr>
+        <p:spPr>
+          <a:xfrm>
+            <a:off x="814546" y="350000"/>
+            <a:ext cx="11810918" cy="480000"/>
+          </a:xfrm>
+          <a:prstGeom prst="rect">
+            <a:avLst/>
+          </a:prstGeom>
+          <a:noFill/>
+        </p:spPr>
+        <p:txBody>
+          <a:bodyPr wrap="square" anchor="ctr" lIns="0" rIns="0" tIns="0" bIns="0">
+            <a:spAutoFit/>
+          </a:bodyPr>
+          <a:lstStyle/>
+          <a:p>
+            <a:pPr algn="l">
+              <a:lnSpc>
+                <a:spcPct val="100000"/>
+              </a:lnSpc>
+              <a:spcAft>
+                <a:spcPts val="0"/>
+              </a:spcAft>
+            </a:pPr>
+            <a:r>
+              <a:rPr sz="2600" b="1">
+                <a:solidFill>
+                  <a:srgbClr val="232323"/>
+                </a:solidFill>
+                <a:latin typeface="游ゴシック"/>
+                <a:ea typeface="游ゴシック"/>
+                <a:cs typeface="游ゴシック"/>
+              </a:rPr>
+              <a:t>全体スケジュール（7月〜10月上旬）</a:t>
+            </a:r>
+          </a:p>
+        </p:txBody>
+      </p:sp>
+      <p:sp>
+        <p:nvSpPr>
+          <p:cNvPr id="3" name="Rectangle 2"/>
           <p:cNvSpPr/>
           <p:nvPr/>
         </p:nvSpPr>
         <p:spPr>
           <a:xfrm>
-            <a:off x="6870005" y="1520000"/>
-            <a:ext cx="5755459" cy="1360000"/>
+            <a:off x="797689" y="820000"/>
+            <a:ext cx="11827398" cy="82000"/>
+          </a:xfrm>
+          <a:prstGeom prst="rect">
+            <a:avLst/>
+          </a:prstGeom>
+          <a:solidFill>
+            <a:srgbClr val="1B5C80"/>
+          </a:solidFill>
+          <a:ln>
+            <a:noFill/>
+          </a:ln>
+          <a:effectLst/>
+        </p:spPr>
+        <p:style>
+          <a:lnRef idx="1">
+            <a:schemeClr val="accent1"/>
+          </a:lnRef>
+          <a:fillRef idx="3">
+            <a:schemeClr val="accent1"/>
+          </a:fillRef>
+          <a:effectRef idx="2">
+            <a:schemeClr val="accent1"/>
+          </a:effectRef>
+          <a:fontRef idx="minor">
+            <a:schemeClr val="lt1"/>
+          </a:fontRef>
+        </p:style>
+        <p:txBody>
+          <a:bodyPr rtlCol="0" anchor="ctr" wrap="square"/>
+          <a:lstStyle/>
+          <a:p>
+            <a:pPr algn="ctr"/>
+          </a:p>
+        </p:txBody>
+      </p:sp>
+      <p:sp>
+        <p:nvSpPr>
+          <p:cNvPr id="4" name="TextBox 3"/>
+          <p:cNvSpPr txBox="1"/>
+          <p:nvPr/>
+        </p:nvSpPr>
+        <p:spPr>
+          <a:xfrm>
+            <a:off x="300000" y="7150000"/>
+            <a:ext cx="7000000" cy="300000"/>
+          </a:xfrm>
+          <a:prstGeom prst="rect">
+            <a:avLst/>
+          </a:prstGeom>
+          <a:noFill/>
+        </p:spPr>
+        <p:txBody>
+          <a:bodyPr wrap="square" anchor="ctr" lIns="0" rIns="0" tIns="0" bIns="0">
+            <a:spAutoFit/>
+          </a:bodyPr>
+          <a:lstStyle/>
+          <a:p>
+            <a:pPr algn="l">
+              <a:lnSpc>
+                <a:spcPct val="100000"/>
+              </a:lnSpc>
+              <a:spcAft>
+                <a:spcPts val="0"/>
+              </a:spcAft>
+            </a:pPr>
+            <a:r>
+              <a:rPr sz="900" b="0">
+                <a:solidFill>
+                  <a:srgbClr val="AEB8BD"/>
+                </a:solidFill>
+                <a:latin typeface="游ゴシック"/>
+                <a:ea typeface="游ゴシック"/>
+                <a:cs typeface="游ゴシック"/>
+              </a:rPr>
+              <a:t>© 2026 Low Code Inc. All rights reserved.</a:t>
+            </a:r>
+          </a:p>
+        </p:txBody>
+      </p:sp>
+      <p:sp>
+        <p:nvSpPr>
+          <p:cNvPr id="5" name="TextBox 4"/>
+          <p:cNvSpPr txBox="1"/>
+          <p:nvPr/>
+        </p:nvSpPr>
+        <p:spPr>
+          <a:xfrm>
+            <a:off x="12650000" y="7060000"/>
+            <a:ext cx="543031" cy="360000"/>
+          </a:xfrm>
+          <a:prstGeom prst="rect">
+            <a:avLst/>
+          </a:prstGeom>
+          <a:noFill/>
+        </p:spPr>
+        <p:txBody>
+          <a:bodyPr wrap="square" anchor="ctr" lIns="0" rIns="0" tIns="0" bIns="0">
+            <a:spAutoFit/>
+          </a:bodyPr>
+          <a:lstStyle/>
+          <a:p>
+            <a:pPr algn="ctr">
+              <a:lnSpc>
+                <a:spcPct val="100000"/>
+              </a:lnSpc>
+              <a:spcAft>
+                <a:spcPts val="0"/>
+              </a:spcAft>
+            </a:pPr>
+            <a:r>
+              <a:rPr sz="1100" b="0">
+                <a:solidFill>
+                  <a:srgbClr val="9BA7AC"/>
+                </a:solidFill>
+                <a:latin typeface="游ゴシック"/>
+                <a:ea typeface="游ゴシック"/>
+                <a:cs typeface="游ゴシック"/>
+              </a:rPr>
+              <a:t>3</a:t>
+            </a:r>
+          </a:p>
+        </p:txBody>
+      </p:sp>
+      <p:sp>
+        <p:nvSpPr>
+          <p:cNvPr id="6" name="Rectangle 5"/>
+          <p:cNvSpPr/>
+          <p:nvPr/>
+        </p:nvSpPr>
+        <p:spPr>
+          <a:xfrm>
+            <a:off x="814546" y="1780000"/>
+            <a:ext cx="11810918" cy="34000"/>
+          </a:xfrm>
+          <a:prstGeom prst="rect">
+            <a:avLst/>
+          </a:prstGeom>
+          <a:solidFill>
+            <a:srgbClr val="DCE6EA"/>
+          </a:solidFill>
+          <a:ln>
+            <a:noFill/>
+          </a:ln>
+          <a:effectLst/>
+        </p:spPr>
+        <p:style>
+          <a:lnRef idx="1">
+            <a:schemeClr val="accent1"/>
+          </a:lnRef>
+          <a:fillRef idx="3">
+            <a:schemeClr val="accent1"/>
+          </a:fillRef>
+          <a:effectRef idx="2">
+            <a:schemeClr val="accent1"/>
+          </a:effectRef>
+          <a:fontRef idx="minor">
+            <a:schemeClr val="lt1"/>
+          </a:fontRef>
+        </p:style>
+        <p:txBody>
+          <a:bodyPr rtlCol="0" anchor="ctr" wrap="square"/>
+          <a:lstStyle/>
+          <a:p>
+            <a:pPr algn="ctr"/>
+          </a:p>
+        </p:txBody>
+      </p:sp>
+      <p:sp>
+        <p:nvSpPr>
+          <p:cNvPr id="7" name="Oval 6"/>
+          <p:cNvSpPr/>
+          <p:nvPr/>
+        </p:nvSpPr>
+        <p:spPr>
+          <a:xfrm>
+            <a:off x="2105910" y="1700000"/>
+            <a:ext cx="190000" cy="190000"/>
+          </a:xfrm>
+          <a:prstGeom prst="ellipse">
+            <a:avLst/>
+          </a:prstGeom>
+          <a:solidFill>
+            <a:srgbClr val="0FA4CC"/>
+          </a:solidFill>
+          <a:ln>
+            <a:noFill/>
+          </a:ln>
+          <a:effectLst/>
+        </p:spPr>
+        <p:style>
+          <a:lnRef idx="1">
+            <a:schemeClr val="accent1"/>
+          </a:lnRef>
+          <a:fillRef idx="3">
+            <a:schemeClr val="accent1"/>
+          </a:fillRef>
+          <a:effectRef idx="2">
+            <a:schemeClr val="accent1"/>
+          </a:effectRef>
+          <a:fontRef idx="minor">
+            <a:schemeClr val="lt1"/>
+          </a:fontRef>
+        </p:style>
+        <p:txBody>
+          <a:bodyPr rtlCol="0" anchor="ctr" lIns="0" rIns="0" tIns="0" bIns="0" wrap="none"/>
+          <a:lstStyle/>
+          <a:p>
+            <a:pPr algn="ctr"/>
+            <a:r>
+              <a:rPr sz="100" b="1">
+                <a:solidFill>
+                  <a:srgbClr val="FFFFFF"/>
+                </a:solidFill>
+                <a:latin typeface="游ゴシック"/>
+                <a:ea typeface="游ゴシック"/>
+                <a:cs typeface="游ゴシック"/>
+              </a:rPr>
+              <a:t/>
+            </a:r>
+          </a:p>
+        </p:txBody>
+      </p:sp>
+      <p:sp>
+        <p:nvSpPr>
+          <p:cNvPr id="8" name="Oval 7"/>
+          <p:cNvSpPr/>
+          <p:nvPr/>
+        </p:nvSpPr>
+        <p:spPr>
+          <a:xfrm>
+            <a:off x="5118639" y="1700000"/>
+            <a:ext cx="190000" cy="190000"/>
+          </a:xfrm>
+          <a:prstGeom prst="ellipse">
+            <a:avLst/>
+          </a:prstGeom>
+          <a:solidFill>
+            <a:srgbClr val="0FA4CC"/>
+          </a:solidFill>
+          <a:ln>
+            <a:noFill/>
+          </a:ln>
+          <a:effectLst/>
+        </p:spPr>
+        <p:style>
+          <a:lnRef idx="1">
+            <a:schemeClr val="accent1"/>
+          </a:lnRef>
+          <a:fillRef idx="3">
+            <a:schemeClr val="accent1"/>
+          </a:fillRef>
+          <a:effectRef idx="2">
+            <a:schemeClr val="accent1"/>
+          </a:effectRef>
+          <a:fontRef idx="minor">
+            <a:schemeClr val="lt1"/>
+          </a:fontRef>
+        </p:style>
+        <p:txBody>
+          <a:bodyPr rtlCol="0" anchor="ctr" lIns="0" rIns="0" tIns="0" bIns="0" wrap="none"/>
+          <a:lstStyle/>
+          <a:p>
+            <a:pPr algn="ctr"/>
+            <a:r>
+              <a:rPr sz="100" b="1">
+                <a:solidFill>
+                  <a:srgbClr val="FFFFFF"/>
+                </a:solidFill>
+                <a:latin typeface="游ゴシック"/>
+                <a:ea typeface="游ゴシック"/>
+                <a:cs typeface="游ゴシック"/>
+              </a:rPr>
+              <a:t/>
+            </a:r>
+          </a:p>
+        </p:txBody>
+      </p:sp>
+      <p:sp>
+        <p:nvSpPr>
+          <p:cNvPr id="9" name="Oval 8"/>
+          <p:cNvSpPr/>
+          <p:nvPr/>
+        </p:nvSpPr>
+        <p:spPr>
+          <a:xfrm>
+            <a:off x="8131368" y="1700000"/>
+            <a:ext cx="190000" cy="190000"/>
+          </a:xfrm>
+          <a:prstGeom prst="ellipse">
+            <a:avLst/>
+          </a:prstGeom>
+          <a:solidFill>
+            <a:srgbClr val="0FA4CC"/>
+          </a:solidFill>
+          <a:ln>
+            <a:noFill/>
+          </a:ln>
+          <a:effectLst/>
+        </p:spPr>
+        <p:style>
+          <a:lnRef idx="1">
+            <a:schemeClr val="accent1"/>
+          </a:lnRef>
+          <a:fillRef idx="3">
+            <a:schemeClr val="accent1"/>
+          </a:fillRef>
+          <a:effectRef idx="2">
+            <a:schemeClr val="accent1"/>
+          </a:effectRef>
+          <a:fontRef idx="minor">
+            <a:schemeClr val="lt1"/>
+          </a:fontRef>
+        </p:style>
+        <p:txBody>
+          <a:bodyPr rtlCol="0" anchor="ctr" lIns="0" rIns="0" tIns="0" bIns="0" wrap="none"/>
+          <a:lstStyle/>
+          <a:p>
+            <a:pPr algn="ctr"/>
+            <a:r>
+              <a:rPr sz="100" b="1">
+                <a:solidFill>
+                  <a:srgbClr val="FFFFFF"/>
+                </a:solidFill>
+                <a:latin typeface="游ゴシック"/>
+                <a:ea typeface="游ゴシック"/>
+                <a:cs typeface="游ゴシック"/>
+              </a:rPr>
+              <a:t/>
+            </a:r>
+          </a:p>
+        </p:txBody>
+      </p:sp>
+      <p:sp>
+        <p:nvSpPr>
+          <p:cNvPr id="10" name="Oval 9"/>
+          <p:cNvSpPr/>
+          <p:nvPr/>
+        </p:nvSpPr>
+        <p:spPr>
+          <a:xfrm>
+            <a:off x="11144097" y="1700000"/>
+            <a:ext cx="190000" cy="190000"/>
+          </a:xfrm>
+          <a:prstGeom prst="ellipse">
+            <a:avLst/>
+          </a:prstGeom>
+          <a:solidFill>
+            <a:srgbClr val="EC856F"/>
+          </a:solidFill>
+          <a:ln>
+            <a:noFill/>
+          </a:ln>
+          <a:effectLst/>
+        </p:spPr>
+        <p:style>
+          <a:lnRef idx="1">
+            <a:schemeClr val="accent1"/>
+          </a:lnRef>
+          <a:fillRef idx="3">
+            <a:schemeClr val="accent1"/>
+          </a:fillRef>
+          <a:effectRef idx="2">
+            <a:schemeClr val="accent1"/>
+          </a:effectRef>
+          <a:fontRef idx="minor">
+            <a:schemeClr val="lt1"/>
+          </a:fontRef>
+        </p:style>
+        <p:txBody>
+          <a:bodyPr rtlCol="0" anchor="ctr" lIns="0" rIns="0" tIns="0" bIns="0" wrap="none"/>
+          <a:lstStyle/>
+          <a:p>
+            <a:pPr algn="ctr"/>
+            <a:r>
+              <a:rPr sz="100" b="1">
+                <a:solidFill>
+                  <a:srgbClr val="FFFFFF"/>
+                </a:solidFill>
+                <a:latin typeface="游ゴシック"/>
+                <a:ea typeface="游ゴシック"/>
+                <a:cs typeface="游ゴシック"/>
+              </a:rPr>
+              <a:t/>
+            </a:r>
+          </a:p>
+        </p:txBody>
+      </p:sp>
+      <p:sp>
+        <p:nvSpPr>
+          <p:cNvPr id="11" name="Rounded Rectangle 10"/>
+          <p:cNvSpPr/>
+          <p:nvPr/>
+        </p:nvSpPr>
+        <p:spPr>
+          <a:xfrm>
+            <a:off x="860910" y="1120000"/>
+            <a:ext cx="2680000" cy="470000"/>
           </a:xfrm>
           <a:prstGeom prst="roundRect">
             <a:avLst>
-              <a:gd name="adj" fmla="val 7000"/>
+              <a:gd name="adj" fmla="val 50000"/>
+            </a:avLst>
+          </a:prstGeom>
+          <a:solidFill>
+            <a:srgbClr val="EC856F"/>
+          </a:solidFill>
+          <a:ln>
+            <a:noFill/>
+          </a:ln>
+          <a:effectLst/>
+          <a:effectLst>
+            <a:outerShdw blurRad="50800" dist="25400" dir="5400000" rotWithShape="0">
+              <a:srgbClr val="8AA6B0">
+                <a:alpha val="36000"/>
+              </a:srgbClr>
+            </a:outerShdw>
+          </a:effectLst>
+        </p:spPr>
+        <p:style>
+          <a:lnRef idx="1">
+            <a:schemeClr val="accent1"/>
+          </a:lnRef>
+          <a:fillRef idx="3">
+            <a:schemeClr val="accent1"/>
+          </a:fillRef>
+          <a:effectRef idx="2">
+            <a:schemeClr val="accent1"/>
+          </a:effectRef>
+          <a:fontRef idx="minor">
+            <a:schemeClr val="lt1"/>
+          </a:fontRef>
+        </p:style>
+        <p:txBody>
+          <a:bodyPr rtlCol="0" anchor="ctr" wrap="square" lIns="0" rIns="0" tIns="0" bIns="0"/>
+          <a:lstStyle/>
+          <a:p>
+            <a:pPr algn="ctr">
+              <a:lnSpc>
+                <a:spcPct val="100000"/>
+              </a:lnSpc>
+              <a:spcAft>
+                <a:spcPts val="0"/>
+              </a:spcAft>
+            </a:pPr>
+            <a:r>
+              <a:rPr sz="1250" b="1">
+                <a:solidFill>
+                  <a:srgbClr val="FFFFFF"/>
+                </a:solidFill>
+                <a:latin typeface="游ゴシック"/>
+                <a:ea typeface="游ゴシック"/>
+                <a:cs typeface="游ゴシック"/>
+              </a:rPr>
+              <a:t>★ 本日：事前相談会②</a:t>
+            </a:r>
+          </a:p>
+        </p:txBody>
+      </p:sp>
+      <p:sp>
+        <p:nvSpPr>
+          <p:cNvPr id="12" name="Isosceles Triangle 11"/>
+          <p:cNvSpPr/>
+          <p:nvPr/>
+        </p:nvSpPr>
+        <p:spPr>
+          <a:xfrm rot="10800000">
+            <a:off x="2130910" y="1590000"/>
+            <a:ext cx="140000" cy="150000"/>
+          </a:xfrm>
+          <a:prstGeom prst="triangle">
+            <a:avLst/>
+          </a:prstGeom>
+          <a:solidFill>
+            <a:srgbClr val="EC856F"/>
+          </a:solidFill>
+          <a:ln>
+            <a:noFill/>
+          </a:ln>
+          <a:effectLst/>
+        </p:spPr>
+        <p:style>
+          <a:lnRef idx="1">
+            <a:schemeClr val="accent1"/>
+          </a:lnRef>
+          <a:fillRef idx="3">
+            <a:schemeClr val="accent1"/>
+          </a:fillRef>
+          <a:effectRef idx="2">
+            <a:schemeClr val="accent1"/>
+          </a:effectRef>
+          <a:fontRef idx="minor">
+            <a:schemeClr val="lt1"/>
+          </a:fontRef>
+        </p:style>
+        <p:txBody>
+          <a:bodyPr rtlCol="0" anchor="ctr"/>
+          <a:lstStyle/>
+          <a:p>
+            <a:pPr algn="ctr"/>
+          </a:p>
+        </p:txBody>
+      </p:sp>
+      <p:sp>
+        <p:nvSpPr>
+          <p:cNvPr id="13" name="Rounded Rectangle 12"/>
+          <p:cNvSpPr/>
+          <p:nvPr/>
+        </p:nvSpPr>
+        <p:spPr>
+          <a:xfrm>
+            <a:off x="3873639" y="1120000"/>
+            <a:ext cx="2680000" cy="470000"/>
+          </a:xfrm>
+          <a:prstGeom prst="roundRect">
+            <a:avLst>
+              <a:gd name="adj" fmla="val 50000"/>
+            </a:avLst>
+          </a:prstGeom>
+          <a:solidFill>
+            <a:srgbClr val="0FA4CC"/>
+          </a:solidFill>
+          <a:ln>
+            <a:noFill/>
+          </a:ln>
+          <a:effectLst/>
+          <a:effectLst>
+            <a:outerShdw blurRad="50800" dist="25400" dir="5400000" rotWithShape="0">
+              <a:srgbClr val="8AA6B0">
+                <a:alpha val="36000"/>
+              </a:srgbClr>
+            </a:outerShdw>
+          </a:effectLst>
+        </p:spPr>
+        <p:style>
+          <a:lnRef idx="1">
+            <a:schemeClr val="accent1"/>
+          </a:lnRef>
+          <a:fillRef idx="3">
+            <a:schemeClr val="accent1"/>
+          </a:fillRef>
+          <a:effectRef idx="2">
+            <a:schemeClr val="accent1"/>
+          </a:effectRef>
+          <a:fontRef idx="minor">
+            <a:schemeClr val="lt1"/>
+          </a:fontRef>
+        </p:style>
+        <p:txBody>
+          <a:bodyPr rtlCol="0" anchor="ctr" wrap="square" lIns="0" rIns="0" tIns="0" bIns="0"/>
+          <a:lstStyle/>
+          <a:p>
+            <a:pPr algn="ctr">
+              <a:lnSpc>
+                <a:spcPct val="100000"/>
+              </a:lnSpc>
+              <a:spcAft>
+                <a:spcPts val="0"/>
+              </a:spcAft>
+            </a:pPr>
+            <a:r>
+              <a:rPr sz="1250" b="1">
+                <a:solidFill>
+                  <a:srgbClr val="FFFFFF"/>
+                </a:solidFill>
+                <a:latin typeface="游ゴシック"/>
+                <a:ea typeface="游ゴシック"/>
+                <a:cs typeface="游ゴシック"/>
+              </a:rPr>
+              <a:t>8月初旬：ライセンス付与</a:t>
+            </a:r>
+          </a:p>
+        </p:txBody>
+      </p:sp>
+      <p:sp>
+        <p:nvSpPr>
+          <p:cNvPr id="14" name="Isosceles Triangle 13"/>
+          <p:cNvSpPr/>
+          <p:nvPr/>
+        </p:nvSpPr>
+        <p:spPr>
+          <a:xfrm rot="10800000">
+            <a:off x="5143639" y="1590000"/>
+            <a:ext cx="140000" cy="150000"/>
+          </a:xfrm>
+          <a:prstGeom prst="triangle">
+            <a:avLst/>
+          </a:prstGeom>
+          <a:solidFill>
+            <a:srgbClr val="0FA4CC"/>
+          </a:solidFill>
+          <a:ln>
+            <a:noFill/>
+          </a:ln>
+          <a:effectLst/>
+        </p:spPr>
+        <p:style>
+          <a:lnRef idx="1">
+            <a:schemeClr val="accent1"/>
+          </a:lnRef>
+          <a:fillRef idx="3">
+            <a:schemeClr val="accent1"/>
+          </a:fillRef>
+          <a:effectRef idx="2">
+            <a:schemeClr val="accent1"/>
+          </a:effectRef>
+          <a:fontRef idx="minor">
+            <a:schemeClr val="lt1"/>
+          </a:fontRef>
+        </p:style>
+        <p:txBody>
+          <a:bodyPr rtlCol="0" anchor="ctr"/>
+          <a:lstStyle/>
+          <a:p>
+            <a:pPr algn="ctr"/>
+          </a:p>
+        </p:txBody>
+      </p:sp>
+      <p:sp>
+        <p:nvSpPr>
+          <p:cNvPr id="15" name="Rounded Rectangle 14"/>
+          <p:cNvSpPr/>
+          <p:nvPr/>
+        </p:nvSpPr>
+        <p:spPr>
+          <a:xfrm>
+            <a:off x="9899097" y="1120000"/>
+            <a:ext cx="2680000" cy="470000"/>
+          </a:xfrm>
+          <a:prstGeom prst="roundRect">
+            <a:avLst>
+              <a:gd name="adj" fmla="val 50000"/>
+            </a:avLst>
+          </a:prstGeom>
+          <a:solidFill>
+            <a:srgbClr val="EC856F"/>
+          </a:solidFill>
+          <a:ln>
+            <a:noFill/>
+          </a:ln>
+          <a:effectLst/>
+          <a:effectLst>
+            <a:outerShdw blurRad="50800" dist="25400" dir="5400000" rotWithShape="0">
+              <a:srgbClr val="8AA6B0">
+                <a:alpha val="36000"/>
+              </a:srgbClr>
+            </a:outerShdw>
+          </a:effectLst>
+        </p:spPr>
+        <p:style>
+          <a:lnRef idx="1">
+            <a:schemeClr val="accent1"/>
+          </a:lnRef>
+          <a:fillRef idx="3">
+            <a:schemeClr val="accent1"/>
+          </a:fillRef>
+          <a:effectRef idx="2">
+            <a:schemeClr val="accent1"/>
+          </a:effectRef>
+          <a:fontRef idx="minor">
+            <a:schemeClr val="lt1"/>
+          </a:fontRef>
+        </p:style>
+        <p:txBody>
+          <a:bodyPr rtlCol="0" anchor="ctr" wrap="square" lIns="0" rIns="0" tIns="0" bIns="0"/>
+          <a:lstStyle/>
+          <a:p>
+            <a:pPr algn="ctr">
+              <a:lnSpc>
+                <a:spcPct val="100000"/>
+              </a:lnSpc>
+              <a:spcAft>
+                <a:spcPts val="0"/>
+              </a:spcAft>
+            </a:pPr>
+            <a:r>
+              <a:rPr sz="1250" b="1">
+                <a:solidFill>
+                  <a:srgbClr val="FFFFFF"/>
+                </a:solidFill>
+                <a:latin typeface="游ゴシック"/>
+                <a:ea typeface="游ゴシック"/>
+                <a:cs typeface="游ゴシック"/>
+              </a:rPr>
+              <a:t>10月1週目：社長・役員報告</a:t>
+            </a:r>
+          </a:p>
+        </p:txBody>
+      </p:sp>
+      <p:sp>
+        <p:nvSpPr>
+          <p:cNvPr id="16" name="Isosceles Triangle 15"/>
+          <p:cNvSpPr/>
+          <p:nvPr/>
+        </p:nvSpPr>
+        <p:spPr>
+          <a:xfrm rot="10800000">
+            <a:off x="11169097" y="1590000"/>
+            <a:ext cx="140000" cy="150000"/>
+          </a:xfrm>
+          <a:prstGeom prst="triangle">
+            <a:avLst/>
+          </a:prstGeom>
+          <a:solidFill>
+            <a:srgbClr val="EC856F"/>
+          </a:solidFill>
+          <a:ln>
+            <a:noFill/>
+          </a:ln>
+          <a:effectLst/>
+        </p:spPr>
+        <p:style>
+          <a:lnRef idx="1">
+            <a:schemeClr val="accent1"/>
+          </a:lnRef>
+          <a:fillRef idx="3">
+            <a:schemeClr val="accent1"/>
+          </a:fillRef>
+          <a:effectRef idx="2">
+            <a:schemeClr val="accent1"/>
+          </a:effectRef>
+          <a:fontRef idx="minor">
+            <a:schemeClr val="lt1"/>
+          </a:fontRef>
+        </p:style>
+        <p:txBody>
+          <a:bodyPr rtlCol="0" anchor="ctr"/>
+          <a:lstStyle/>
+          <a:p>
+            <a:pPr algn="ctr"/>
+          </a:p>
+        </p:txBody>
+      </p:sp>
+      <p:sp>
+        <p:nvSpPr>
+          <p:cNvPr id="17" name="Rounded Rectangle 16"/>
+          <p:cNvSpPr/>
+          <p:nvPr/>
+        </p:nvSpPr>
+        <p:spPr>
+          <a:xfrm>
+            <a:off x="814546" y="2440000"/>
+            <a:ext cx="2772729" cy="3760000"/>
+          </a:xfrm>
+          <a:prstGeom prst="roundRect">
+            <a:avLst>
+              <a:gd name="adj" fmla="val 5000"/>
             </a:avLst>
           </a:prstGeom>
           <a:solidFill>
@@ -5112,7 +5125,7 @@
           <a:effectLst>
             <a:outerShdw blurRad="50800" dist="25400" dir="5400000" rotWithShape="0">
               <a:srgbClr val="8AA6B0">
-                <a:alpha val="38000"/>
+                <a:alpha val="36000"/>
               </a:srgbClr>
             </a:outerShdw>
           </a:effectLst>
@@ -5141,14 +5154,14 @@
       </p:sp>
       <p:sp>
         <p:nvSpPr>
-          <p:cNvPr id="13" name="Oval 12"/>
+          <p:cNvPr id="18" name="Oval 17"/>
           <p:cNvSpPr/>
           <p:nvPr/>
         </p:nvSpPr>
         <p:spPr>
           <a:xfrm>
-            <a:off x="7070005" y="1720000"/>
-            <a:ext cx="430000" cy="430000"/>
+            <a:off x="1044546" y="2670000"/>
+            <a:ext cx="470000" cy="470000"/>
           </a:xfrm>
           <a:prstGeom prst="ellipse">
             <a:avLst/>
@@ -5189,21 +5202,21 @@
                 <a:ea typeface="游ゴシック"/>
                 <a:cs typeface="游ゴシック"/>
               </a:rPr>
-              <a:t>2</a:t>
-            </a:r>
-          </a:p>
-        </p:txBody>
-      </p:sp>
-      <p:sp>
-        <p:nvSpPr>
-          <p:cNvPr id="14" name="TextBox 13"/>
+              <a:t>①</a:t>
+            </a:r>
+          </a:p>
+        </p:txBody>
+      </p:sp>
+      <p:sp>
+        <p:nvSpPr>
+          <p:cNvPr id="19" name="TextBox 18"/>
           <p:cNvSpPr txBox="1"/>
           <p:nvPr/>
         </p:nvSpPr>
         <p:spPr>
           <a:xfrm>
-            <a:off x="7630005" y="1740000"/>
-            <a:ext cx="4815459" cy="400000"/>
+            <a:off x="1604546" y="2670000"/>
+            <a:ext cx="1922729" cy="500000"/>
           </a:xfrm>
           <a:prstGeom prst="rect">
             <a:avLst/>
@@ -5225,29 +5238,29 @@
               </a:spcAft>
             </a:pPr>
             <a:r>
-              <a:rPr sz="1600" b="1">
-                <a:solidFill>
-                  <a:srgbClr val="1B5C80"/>
-                </a:solidFill>
-                <a:latin typeface="游ゴシック"/>
-                <a:ea typeface="游ゴシック"/>
-                <a:cs typeface="游ゴシック"/>
-              </a:rPr>
-              <a:t>技術的なお困りごと</a:t>
-            </a:r>
-          </a:p>
-        </p:txBody>
-      </p:sp>
-      <p:sp>
-        <p:nvSpPr>
-          <p:cNvPr id="15" name="TextBox 14"/>
+              <a:rPr sz="2300" b="1">
+                <a:solidFill>
+                  <a:srgbClr val="0FA4CC"/>
+                </a:solidFill>
+                <a:latin typeface="游ゴシック"/>
+                <a:ea typeface="游ゴシック"/>
+                <a:cs typeface="游ゴシック"/>
+              </a:rPr>
+              <a:t>7月</a:t>
+            </a:r>
+          </a:p>
+        </p:txBody>
+      </p:sp>
+      <p:sp>
+        <p:nvSpPr>
+          <p:cNvPr id="20" name="TextBox 19"/>
           <p:cNvSpPr txBox="1"/>
           <p:nvPr/>
         </p:nvSpPr>
         <p:spPr>
           <a:xfrm>
-            <a:off x="7090005" y="2240000"/>
-            <a:ext cx="5315459" cy="540000"/>
+            <a:off x="1044546" y="3260000"/>
+            <a:ext cx="2312729" cy="380000"/>
           </a:xfrm>
           <a:prstGeom prst="rect">
             <a:avLst/>
@@ -5256,50 +5269,6 @@
         </p:spPr>
         <p:txBody>
           <a:bodyPr wrap="square" anchor="t" lIns="0" rIns="0" tIns="0" bIns="0">
-            <a:spAutoFit/>
-          </a:bodyPr>
-          <a:lstStyle/>
-          <a:p>
-            <a:pPr algn="l">
-              <a:lnSpc>
-                <a:spcPct val="120000"/>
-              </a:lnSpc>
-              <a:spcAft>
-                <a:spcPts val="0"/>
-              </a:spcAft>
-            </a:pPr>
-            <a:r>
-              <a:rPr sz="1300" b="0">
-                <a:solidFill>
-                  <a:srgbClr val="232323"/>
-                </a:solidFill>
-                <a:latin typeface="游ゴシック"/>
-                <a:ea typeface="游ゴシック"/>
-                <a:cs typeface="游ゴシック"/>
-              </a:rPr>
-              <a:t>技術面で詰まっている点があれば、この場で助言します。</a:t>
-            </a:r>
-          </a:p>
-        </p:txBody>
-      </p:sp>
-      <p:sp>
-        <p:nvSpPr>
-          <p:cNvPr id="16" name="TextBox 15"/>
-          <p:cNvSpPr txBox="1"/>
-          <p:nvPr/>
-        </p:nvSpPr>
-        <p:spPr>
-          <a:xfrm>
-            <a:off x="814546" y="3030000"/>
-            <a:ext cx="11810918" cy="380000"/>
-          </a:xfrm>
-          <a:prstGeom prst="rect">
-            <a:avLst/>
-          </a:prstGeom>
-          <a:noFill/>
-        </p:spPr>
-        <p:txBody>
-          <a:bodyPr wrap="square" anchor="ctr" lIns="0" rIns="0" tIns="0" bIns="0">
             <a:spAutoFit/>
           </a:bodyPr>
           <a:lstStyle/>
@@ -5313,45 +5282,238 @@
               </a:spcAft>
             </a:pPr>
             <a:r>
+              <a:rPr sz="1300" b="1">
+                <a:solidFill>
+                  <a:srgbClr val="0FA4CC"/>
+                </a:solidFill>
+                <a:latin typeface="游ゴシック"/>
+                <a:ea typeface="游ゴシック"/>
+                <a:cs typeface="游ゴシック"/>
+              </a:rPr>
+              <a:t>企画・準備</a:t>
+            </a:r>
+          </a:p>
+        </p:txBody>
+      </p:sp>
+      <p:sp>
+        <p:nvSpPr>
+          <p:cNvPr id="21" name="TextBox 20"/>
+          <p:cNvSpPr txBox="1"/>
+          <p:nvPr/>
+        </p:nvSpPr>
+        <p:spPr>
+          <a:xfrm>
+            <a:off x="1044546" y="3760000"/>
+            <a:ext cx="2312729" cy="2260000"/>
+          </a:xfrm>
+          <a:prstGeom prst="rect">
+            <a:avLst/>
+          </a:prstGeom>
+          <a:noFill/>
+        </p:spPr>
+        <p:txBody>
+          <a:bodyPr wrap="square" anchor="t" lIns="0" rIns="0" tIns="0" bIns="0">
+            <a:spAutoFit/>
+          </a:bodyPr>
+          <a:lstStyle/>
+          <a:p>
+            <a:pPr algn="l">
+              <a:lnSpc>
+                <a:spcPct val="114000"/>
+              </a:lnSpc>
+              <a:spcAft>
+                <a:spcPts val="1200"/>
+              </a:spcAft>
+            </a:pPr>
+            <a:r>
               <a:rPr sz="1200" b="0">
                 <a:solidFill>
-                  <a:srgbClr val="EC856F"/>
-                </a:solidFill>
-                <a:latin typeface="游ゴシック"/>
-                <a:ea typeface="游ゴシック"/>
-                <a:cs typeface="游ゴシック"/>
-              </a:rPr>
-              <a:t>💬 </a:t>
-            </a:r>
-            <a:r>
-              <a:rPr sz="1300" b="1">
-                <a:solidFill>
-                  <a:srgbClr val="5A6E77"/>
-                </a:solidFill>
-                <a:latin typeface="游ゴシック"/>
-                <a:ea typeface="游ゴシック"/>
-                <a:cs typeface="游ゴシック"/>
-              </a:rPr>
-              <a:t>すでにお持ちの質問があれば、ぜひこの場でご発言ください。</a:t>
-            </a:r>
-          </a:p>
-        </p:txBody>
-      </p:sp>
-      <p:sp>
-        <p:nvSpPr>
-          <p:cNvPr id="17" name="Rounded Rectangle 16"/>
+                  <a:srgbClr val="0FA4CC"/>
+                </a:solidFill>
+                <a:latin typeface="游ゴシック"/>
+                <a:ea typeface="游ゴシック"/>
+                <a:cs typeface="游ゴシック"/>
+              </a:rPr>
+              <a:t>・</a:t>
+            </a:r>
+            <a:r>
+              <a:rPr sz="1250" b="0">
+                <a:solidFill>
+                  <a:srgbClr val="232323"/>
+                </a:solidFill>
+                <a:latin typeface="游ゴシック"/>
+                <a:ea typeface="游ゴシック"/>
+                <a:cs typeface="游ゴシック"/>
+              </a:rPr>
+              <a:t>チーム編成</a:t>
+            </a:r>
+          </a:p>
+          <a:p>
+            <a:pPr algn="l">
+              <a:lnSpc>
+                <a:spcPct val="114000"/>
+              </a:lnSpc>
+              <a:spcAft>
+                <a:spcPts val="1200"/>
+              </a:spcAft>
+            </a:pPr>
+            <a:r>
+              <a:rPr sz="1200" b="0">
+                <a:solidFill>
+                  <a:srgbClr val="0FA4CC"/>
+                </a:solidFill>
+                <a:latin typeface="游ゴシック"/>
+                <a:ea typeface="游ゴシック"/>
+                <a:cs typeface="游ゴシック"/>
+              </a:rPr>
+              <a:t>・</a:t>
+            </a:r>
+            <a:r>
+              <a:rPr sz="1250" b="0">
+                <a:solidFill>
+                  <a:srgbClr val="232323"/>
+                </a:solidFill>
+                <a:latin typeface="游ゴシック"/>
+                <a:ea typeface="游ゴシック"/>
+                <a:cs typeface="游ゴシック"/>
+              </a:rPr>
+              <a:t>企画案の作成</a:t>
+            </a:r>
+          </a:p>
+          <a:p>
+            <a:pPr algn="l">
+              <a:lnSpc>
+                <a:spcPct val="114000"/>
+              </a:lnSpc>
+              <a:spcAft>
+                <a:spcPts val="1200"/>
+              </a:spcAft>
+            </a:pPr>
+            <a:r>
+              <a:rPr sz="1200" b="0">
+                <a:solidFill>
+                  <a:srgbClr val="0FA4CC"/>
+                </a:solidFill>
+                <a:latin typeface="游ゴシック"/>
+                <a:ea typeface="游ゴシック"/>
+                <a:cs typeface="游ゴシック"/>
+              </a:rPr>
+              <a:t>・</a:t>
+            </a:r>
+            <a:r>
+              <a:rPr sz="1250" b="0">
+                <a:solidFill>
+                  <a:srgbClr val="232323"/>
+                </a:solidFill>
+                <a:latin typeface="游ゴシック"/>
+                <a:ea typeface="游ゴシック"/>
+                <a:cs typeface="游ゴシック"/>
+              </a:rPr>
+              <a:t>Copilot Studio／Power Automate 研修</a:t>
+            </a:r>
+          </a:p>
+          <a:p>
+            <a:pPr algn="l">
+              <a:lnSpc>
+                <a:spcPct val="114000"/>
+              </a:lnSpc>
+              <a:spcAft>
+                <a:spcPts val="1200"/>
+              </a:spcAft>
+            </a:pPr>
+            <a:r>
+              <a:rPr sz="1200" b="0">
+                <a:solidFill>
+                  <a:srgbClr val="0FA4CC"/>
+                </a:solidFill>
+                <a:latin typeface="游ゴシック"/>
+                <a:ea typeface="游ゴシック"/>
+                <a:cs typeface="游ゴシック"/>
+              </a:rPr>
+              <a:t>・</a:t>
+            </a:r>
+            <a:r>
+              <a:rPr sz="1250" b="0">
+                <a:solidFill>
+                  <a:srgbClr val="232323"/>
+                </a:solidFill>
+                <a:latin typeface="游ゴシック"/>
+                <a:ea typeface="游ゴシック"/>
+                <a:cs typeface="游ゴシック"/>
+              </a:rPr>
+              <a:t>事前相談会 ①・②</a:t>
+            </a:r>
+          </a:p>
+        </p:txBody>
+      </p:sp>
+      <p:sp>
+        <p:nvSpPr>
+          <p:cNvPr id="22" name="Rounded Rectangle 21"/>
           <p:cNvSpPr/>
           <p:nvPr/>
         </p:nvSpPr>
         <p:spPr>
           <a:xfrm>
-            <a:off x="814546" y="3510000"/>
-            <a:ext cx="300000" cy="300000"/>
+            <a:off x="3827275" y="2440000"/>
+            <a:ext cx="2772729" cy="3760000"/>
           </a:xfrm>
           <a:prstGeom prst="roundRect">
             <a:avLst>
-              <a:gd name="adj" fmla="val 28000"/>
+              <a:gd name="adj" fmla="val 5000"/>
             </a:avLst>
+          </a:prstGeom>
+          <a:solidFill>
+            <a:srgbClr val="EAF6FB"/>
+          </a:solidFill>
+          <a:ln w="9525">
+            <a:solidFill>
+              <a:srgbClr val="9FD8EA"/>
+            </a:solidFill>
+          </a:ln>
+          <a:effectLst/>
+          <a:effectLst>
+            <a:outerShdw blurRad="50800" dist="25400" dir="5400000" rotWithShape="0">
+              <a:srgbClr val="8AA6B0">
+                <a:alpha val="36000"/>
+              </a:srgbClr>
+            </a:outerShdw>
+          </a:effectLst>
+        </p:spPr>
+        <p:style>
+          <a:lnRef idx="1">
+            <a:schemeClr val="accent1"/>
+          </a:lnRef>
+          <a:fillRef idx="3">
+            <a:schemeClr val="accent1"/>
+          </a:fillRef>
+          <a:effectRef idx="2">
+            <a:schemeClr val="accent1"/>
+          </a:effectRef>
+          <a:fontRef idx="minor">
+            <a:schemeClr val="lt1"/>
+          </a:fontRef>
+        </p:style>
+        <p:txBody>
+          <a:bodyPr rtlCol="0" anchor="ctr" wrap="square"/>
+          <a:lstStyle/>
+          <a:p>
+            <a:pPr algn="ctr"/>
+          </a:p>
+        </p:txBody>
+      </p:sp>
+      <p:sp>
+        <p:nvSpPr>
+          <p:cNvPr id="23" name="Oval 22"/>
+          <p:cNvSpPr/>
+          <p:nvPr/>
+        </p:nvSpPr>
+        <p:spPr>
+          <a:xfrm>
+            <a:off x="4057275" y="2670000"/>
+            <a:ext cx="470000" cy="470000"/>
+          </a:xfrm>
+          <a:prstGeom prst="ellipse">
+            <a:avLst/>
           </a:prstGeom>
           <a:solidFill>
             <a:srgbClr val="0FA4CC"/>
@@ -5376,23 +5538,34 @@
           </a:fontRef>
         </p:style>
         <p:txBody>
-          <a:bodyPr rtlCol="0" anchor="ctr" wrap="square"/>
+          <a:bodyPr rtlCol="0" anchor="ctr" lIns="0" rIns="0" tIns="0" bIns="0" wrap="none"/>
           <a:lstStyle/>
           <a:p>
             <a:pPr algn="ctr"/>
-          </a:p>
-        </p:txBody>
-      </p:sp>
-      <p:sp>
-        <p:nvSpPr>
-          <p:cNvPr id="18" name="TextBox 17"/>
+            <a:r>
+              <a:rPr sz="1700" b="1">
+                <a:solidFill>
+                  <a:srgbClr val="FFFFFF"/>
+                </a:solidFill>
+                <a:latin typeface="游ゴシック"/>
+                <a:ea typeface="游ゴシック"/>
+                <a:cs typeface="游ゴシック"/>
+              </a:rPr>
+              <a:t>②</a:t>
+            </a:r>
+          </a:p>
+        </p:txBody>
+      </p:sp>
+      <p:sp>
+        <p:nvSpPr>
+          <p:cNvPr id="24" name="TextBox 23"/>
           <p:cNvSpPr txBox="1"/>
           <p:nvPr/>
         </p:nvSpPr>
         <p:spPr>
           <a:xfrm>
-            <a:off x="1264546" y="3470000"/>
-            <a:ext cx="11360918" cy="420000"/>
+            <a:off x="4617275" y="2670000"/>
+            <a:ext cx="1922729" cy="500000"/>
           </a:xfrm>
           <a:prstGeom prst="rect">
             <a:avLst/>
@@ -5414,7 +5587,106 @@
               </a:spcAft>
             </a:pPr>
             <a:r>
-              <a:rPr sz="1650" b="1">
+              <a:rPr sz="2300" b="1">
+                <a:solidFill>
+                  <a:srgbClr val="0FA4CC"/>
+                </a:solidFill>
+                <a:latin typeface="游ゴシック"/>
+                <a:ea typeface="游ゴシック"/>
+                <a:cs typeface="游ゴシック"/>
+              </a:rPr>
+              <a:t>8月</a:t>
+            </a:r>
+          </a:p>
+        </p:txBody>
+      </p:sp>
+      <p:sp>
+        <p:nvSpPr>
+          <p:cNvPr id="25" name="TextBox 24"/>
+          <p:cNvSpPr txBox="1"/>
+          <p:nvPr/>
+        </p:nvSpPr>
+        <p:spPr>
+          <a:xfrm>
+            <a:off x="4057275" y="3260000"/>
+            <a:ext cx="2312729" cy="380000"/>
+          </a:xfrm>
+          <a:prstGeom prst="rect">
+            <a:avLst/>
+          </a:prstGeom>
+          <a:noFill/>
+        </p:spPr>
+        <p:txBody>
+          <a:bodyPr wrap="square" anchor="t" lIns="0" rIns="0" tIns="0" bIns="0">
+            <a:spAutoFit/>
+          </a:bodyPr>
+          <a:lstStyle/>
+          <a:p>
+            <a:pPr algn="l">
+              <a:lnSpc>
+                <a:spcPct val="100000"/>
+              </a:lnSpc>
+              <a:spcAft>
+                <a:spcPts val="0"/>
+              </a:spcAft>
+            </a:pPr>
+            <a:r>
+              <a:rPr sz="1300" b="1">
+                <a:solidFill>
+                  <a:srgbClr val="0FA4CC"/>
+                </a:solidFill>
+                <a:latin typeface="游ゴシック"/>
+                <a:ea typeface="游ゴシック"/>
+                <a:cs typeface="游ゴシック"/>
+              </a:rPr>
+              <a:t>構築・検証</a:t>
+            </a:r>
+          </a:p>
+        </p:txBody>
+      </p:sp>
+      <p:sp>
+        <p:nvSpPr>
+          <p:cNvPr id="26" name="TextBox 25"/>
+          <p:cNvSpPr txBox="1"/>
+          <p:nvPr/>
+        </p:nvSpPr>
+        <p:spPr>
+          <a:xfrm>
+            <a:off x="4057275" y="3760000"/>
+            <a:ext cx="2312729" cy="2260000"/>
+          </a:xfrm>
+          <a:prstGeom prst="rect">
+            <a:avLst/>
+          </a:prstGeom>
+          <a:noFill/>
+        </p:spPr>
+        <p:txBody>
+          <a:bodyPr wrap="square" anchor="t" lIns="0" rIns="0" tIns="0" bIns="0">
+            <a:spAutoFit/>
+          </a:bodyPr>
+          <a:lstStyle/>
+          <a:p>
+            <a:pPr algn="l">
+              <a:lnSpc>
+                <a:spcPct val="114000"/>
+              </a:lnSpc>
+              <a:spcAft>
+                <a:spcPts val="1200"/>
+              </a:spcAft>
+            </a:pPr>
+            <a:r>
+              <a:rPr sz="1200" b="0">
+                <a:solidFill>
+                  <a:srgbClr val="0FA4CC"/>
+                </a:solidFill>
+                <a:latin typeface="游ゴシック"/>
+                <a:ea typeface="游ゴシック"/>
+                <a:cs typeface="游ゴシック"/>
+              </a:rPr>
+              <a:t>・</a:t>
+            </a:r>
+            <a:r>
+              <a:rPr sz="1250" b="0">
                 <a:solidFill>
                   <a:srgbClr val="232323"/>
                 </a:solidFill>
@@ -5422,25 +5694,406 @@
                 <a:ea typeface="游ゴシック"/>
                 <a:cs typeface="游ゴシック"/>
               </a:rPr>
-              <a:t>ガイドライン準拠の確認（M365内での構成が前提です）</a:t>
-            </a:r>
-          </a:p>
-        </p:txBody>
-      </p:sp>
-      <p:sp>
-        <p:nvSpPr>
-          <p:cNvPr id="19" name="Rounded Rectangle 18"/>
+              <a:t>ソリューションの構築</a:t>
+            </a:r>
+          </a:p>
+          <a:p>
+            <a:pPr algn="l">
+              <a:lnSpc>
+                <a:spcPct val="114000"/>
+              </a:lnSpc>
+              <a:spcAft>
+                <a:spcPts val="1200"/>
+              </a:spcAft>
+            </a:pPr>
+            <a:r>
+              <a:rPr sz="1200" b="0">
+                <a:solidFill>
+                  <a:srgbClr val="0FA4CC"/>
+                </a:solidFill>
+                <a:latin typeface="游ゴシック"/>
+                <a:ea typeface="游ゴシック"/>
+                <a:cs typeface="游ゴシック"/>
+              </a:rPr>
+              <a:t>・</a:t>
+            </a:r>
+            <a:r>
+              <a:rPr sz="1250" b="0">
+                <a:solidFill>
+                  <a:srgbClr val="232323"/>
+                </a:solidFill>
+                <a:latin typeface="游ゴシック"/>
+                <a:ea typeface="游ゴシック"/>
+                <a:cs typeface="游ゴシック"/>
+              </a:rPr>
+              <a:t>業務適用性の検証</a:t>
+            </a:r>
+          </a:p>
+        </p:txBody>
+      </p:sp>
+      <p:sp>
+        <p:nvSpPr>
+          <p:cNvPr id="27" name="Rounded Rectangle 26"/>
           <p:cNvSpPr/>
           <p:nvPr/>
         </p:nvSpPr>
         <p:spPr>
           <a:xfrm>
-            <a:off x="814546" y="4030000"/>
-            <a:ext cx="3776972" cy="2360000"/>
+            <a:off x="6840004" y="2440000"/>
+            <a:ext cx="2772729" cy="3760000"/>
           </a:xfrm>
           <a:prstGeom prst="roundRect">
             <a:avLst>
-              <a:gd name="adj" fmla="val 6000"/>
+              <a:gd name="adj" fmla="val 5000"/>
+            </a:avLst>
+          </a:prstGeom>
+          <a:solidFill>
+            <a:srgbClr val="EAF6FB"/>
+          </a:solidFill>
+          <a:ln w="9525">
+            <a:solidFill>
+              <a:srgbClr val="9FD8EA"/>
+            </a:solidFill>
+          </a:ln>
+          <a:effectLst/>
+          <a:effectLst>
+            <a:outerShdw blurRad="50800" dist="25400" dir="5400000" rotWithShape="0">
+              <a:srgbClr val="8AA6B0">
+                <a:alpha val="36000"/>
+              </a:srgbClr>
+            </a:outerShdw>
+          </a:effectLst>
+        </p:spPr>
+        <p:style>
+          <a:lnRef idx="1">
+            <a:schemeClr val="accent1"/>
+          </a:lnRef>
+          <a:fillRef idx="3">
+            <a:schemeClr val="accent1"/>
+          </a:fillRef>
+          <a:effectRef idx="2">
+            <a:schemeClr val="accent1"/>
+          </a:effectRef>
+          <a:fontRef idx="minor">
+            <a:schemeClr val="lt1"/>
+          </a:fontRef>
+        </p:style>
+        <p:txBody>
+          <a:bodyPr rtlCol="0" anchor="ctr" wrap="square"/>
+          <a:lstStyle/>
+          <a:p>
+            <a:pPr algn="ctr"/>
+          </a:p>
+        </p:txBody>
+      </p:sp>
+      <p:sp>
+        <p:nvSpPr>
+          <p:cNvPr id="28" name="Oval 27"/>
+          <p:cNvSpPr/>
+          <p:nvPr/>
+        </p:nvSpPr>
+        <p:spPr>
+          <a:xfrm>
+            <a:off x="7070004" y="2670000"/>
+            <a:ext cx="470000" cy="470000"/>
+          </a:xfrm>
+          <a:prstGeom prst="ellipse">
+            <a:avLst/>
+          </a:prstGeom>
+          <a:solidFill>
+            <a:srgbClr val="0FA4CC"/>
+          </a:solidFill>
+          <a:ln>
+            <a:noFill/>
+          </a:ln>
+          <a:effectLst/>
+        </p:spPr>
+        <p:style>
+          <a:lnRef idx="1">
+            <a:schemeClr val="accent1"/>
+          </a:lnRef>
+          <a:fillRef idx="3">
+            <a:schemeClr val="accent1"/>
+          </a:fillRef>
+          <a:effectRef idx="2">
+            <a:schemeClr val="accent1"/>
+          </a:effectRef>
+          <a:fontRef idx="minor">
+            <a:schemeClr val="lt1"/>
+          </a:fontRef>
+        </p:style>
+        <p:txBody>
+          <a:bodyPr rtlCol="0" anchor="ctr" lIns="0" rIns="0" tIns="0" bIns="0" wrap="none"/>
+          <a:lstStyle/>
+          <a:p>
+            <a:pPr algn="ctr"/>
+            <a:r>
+              <a:rPr sz="1700" b="1">
+                <a:solidFill>
+                  <a:srgbClr val="FFFFFF"/>
+                </a:solidFill>
+                <a:latin typeface="游ゴシック"/>
+                <a:ea typeface="游ゴシック"/>
+                <a:cs typeface="游ゴシック"/>
+              </a:rPr>
+              <a:t>③</a:t>
+            </a:r>
+          </a:p>
+        </p:txBody>
+      </p:sp>
+      <p:sp>
+        <p:nvSpPr>
+          <p:cNvPr id="29" name="TextBox 28"/>
+          <p:cNvSpPr txBox="1"/>
+          <p:nvPr/>
+        </p:nvSpPr>
+        <p:spPr>
+          <a:xfrm>
+            <a:off x="7630004" y="2670000"/>
+            <a:ext cx="1922729" cy="500000"/>
+          </a:xfrm>
+          <a:prstGeom prst="rect">
+            <a:avLst/>
+          </a:prstGeom>
+          <a:noFill/>
+        </p:spPr>
+        <p:txBody>
+          <a:bodyPr wrap="square" anchor="ctr" lIns="0" rIns="0" tIns="0" bIns="0">
+            <a:spAutoFit/>
+          </a:bodyPr>
+          <a:lstStyle/>
+          <a:p>
+            <a:pPr algn="l">
+              <a:lnSpc>
+                <a:spcPct val="100000"/>
+              </a:lnSpc>
+              <a:spcAft>
+                <a:spcPts val="0"/>
+              </a:spcAft>
+            </a:pPr>
+            <a:r>
+              <a:rPr sz="2300" b="1">
+                <a:solidFill>
+                  <a:srgbClr val="0FA4CC"/>
+                </a:solidFill>
+                <a:latin typeface="游ゴシック"/>
+                <a:ea typeface="游ゴシック"/>
+                <a:cs typeface="游ゴシック"/>
+              </a:rPr>
+              <a:t>9月</a:t>
+            </a:r>
+          </a:p>
+        </p:txBody>
+      </p:sp>
+      <p:sp>
+        <p:nvSpPr>
+          <p:cNvPr id="30" name="TextBox 29"/>
+          <p:cNvSpPr txBox="1"/>
+          <p:nvPr/>
+        </p:nvSpPr>
+        <p:spPr>
+          <a:xfrm>
+            <a:off x="7070004" y="3260000"/>
+            <a:ext cx="2312729" cy="380000"/>
+          </a:xfrm>
+          <a:prstGeom prst="rect">
+            <a:avLst/>
+          </a:prstGeom>
+          <a:noFill/>
+        </p:spPr>
+        <p:txBody>
+          <a:bodyPr wrap="square" anchor="t" lIns="0" rIns="0" tIns="0" bIns="0">
+            <a:spAutoFit/>
+          </a:bodyPr>
+          <a:lstStyle/>
+          <a:p>
+            <a:pPr algn="l">
+              <a:lnSpc>
+                <a:spcPct val="100000"/>
+              </a:lnSpc>
+              <a:spcAft>
+                <a:spcPts val="0"/>
+              </a:spcAft>
+            </a:pPr>
+            <a:r>
+              <a:rPr sz="1300" b="1">
+                <a:solidFill>
+                  <a:srgbClr val="0FA4CC"/>
+                </a:solidFill>
+                <a:latin typeface="游ゴシック"/>
+                <a:ea typeface="游ゴシック"/>
+                <a:cs typeface="游ゴシック"/>
+              </a:rPr>
+              <a:t>報告準備</a:t>
+            </a:r>
+          </a:p>
+        </p:txBody>
+      </p:sp>
+      <p:sp>
+        <p:nvSpPr>
+          <p:cNvPr id="31" name="TextBox 30"/>
+          <p:cNvSpPr txBox="1"/>
+          <p:nvPr/>
+        </p:nvSpPr>
+        <p:spPr>
+          <a:xfrm>
+            <a:off x="7070004" y="3760000"/>
+            <a:ext cx="2312729" cy="2260000"/>
+          </a:xfrm>
+          <a:prstGeom prst="rect">
+            <a:avLst/>
+          </a:prstGeom>
+          <a:noFill/>
+        </p:spPr>
+        <p:txBody>
+          <a:bodyPr wrap="square" anchor="t" lIns="0" rIns="0" tIns="0" bIns="0">
+            <a:spAutoFit/>
+          </a:bodyPr>
+          <a:lstStyle/>
+          <a:p>
+            <a:pPr algn="l">
+              <a:lnSpc>
+                <a:spcPct val="114000"/>
+              </a:lnSpc>
+              <a:spcAft>
+                <a:spcPts val="1200"/>
+              </a:spcAft>
+            </a:pPr>
+            <a:r>
+              <a:rPr sz="1200" b="0">
+                <a:solidFill>
+                  <a:srgbClr val="0FA4CC"/>
+                </a:solidFill>
+                <a:latin typeface="游ゴシック"/>
+                <a:ea typeface="游ゴシック"/>
+                <a:cs typeface="游ゴシック"/>
+              </a:rPr>
+              <a:t>・</a:t>
+            </a:r>
+            <a:r>
+              <a:rPr sz="1250" b="0">
+                <a:solidFill>
+                  <a:srgbClr val="232323"/>
+                </a:solidFill>
+                <a:latin typeface="游ゴシック"/>
+                <a:ea typeface="游ゴシック"/>
+                <a:cs typeface="游ゴシック"/>
+              </a:rPr>
+              <a:t>デモ検証</a:t>
+            </a:r>
+          </a:p>
+          <a:p>
+            <a:pPr algn="l">
+              <a:lnSpc>
+                <a:spcPct val="114000"/>
+              </a:lnSpc>
+              <a:spcAft>
+                <a:spcPts val="1200"/>
+              </a:spcAft>
+            </a:pPr>
+            <a:r>
+              <a:rPr sz="1200" b="0">
+                <a:solidFill>
+                  <a:srgbClr val="0FA4CC"/>
+                </a:solidFill>
+                <a:latin typeface="游ゴシック"/>
+                <a:ea typeface="游ゴシック"/>
+                <a:cs typeface="游ゴシック"/>
+              </a:rPr>
+              <a:t>・</a:t>
+            </a:r>
+            <a:r>
+              <a:rPr sz="1250" b="0">
+                <a:solidFill>
+                  <a:srgbClr val="232323"/>
+                </a:solidFill>
+                <a:latin typeface="游ゴシック"/>
+                <a:ea typeface="游ゴシック"/>
+                <a:cs typeface="游ゴシック"/>
+              </a:rPr>
+              <a:t>報告資料の作成</a:t>
+            </a:r>
+          </a:p>
+          <a:p>
+            <a:pPr algn="l">
+              <a:lnSpc>
+                <a:spcPct val="114000"/>
+              </a:lnSpc>
+              <a:spcAft>
+                <a:spcPts val="1200"/>
+              </a:spcAft>
+            </a:pPr>
+            <a:r>
+              <a:rPr sz="1200" b="0">
+                <a:solidFill>
+                  <a:srgbClr val="0FA4CC"/>
+                </a:solidFill>
+                <a:latin typeface="游ゴシック"/>
+                <a:ea typeface="游ゴシック"/>
+                <a:cs typeface="游ゴシック"/>
+              </a:rPr>
+              <a:t>・</a:t>
+            </a:r>
+            <a:r>
+              <a:rPr sz="1250" b="0">
+                <a:solidFill>
+                  <a:srgbClr val="232323"/>
+                </a:solidFill>
+                <a:latin typeface="游ゴシック"/>
+                <a:ea typeface="游ゴシック"/>
+                <a:cs typeface="游ゴシック"/>
+              </a:rPr>
+              <a:t>展開計画の整理</a:t>
+            </a:r>
+          </a:p>
+          <a:p>
+            <a:pPr algn="l">
+              <a:lnSpc>
+                <a:spcPct val="114000"/>
+              </a:lnSpc>
+              <a:spcAft>
+                <a:spcPts val="1200"/>
+              </a:spcAft>
+            </a:pPr>
+            <a:r>
+              <a:rPr sz="1200" b="0">
+                <a:solidFill>
+                  <a:srgbClr val="0FA4CC"/>
+                </a:solidFill>
+                <a:latin typeface="游ゴシック"/>
+                <a:ea typeface="游ゴシック"/>
+                <a:cs typeface="游ゴシック"/>
+              </a:rPr>
+              <a:t>・</a:t>
+            </a:r>
+            <a:r>
+              <a:rPr sz="1250" b="0">
+                <a:solidFill>
+                  <a:srgbClr val="232323"/>
+                </a:solidFill>
+                <a:latin typeface="游ゴシック"/>
+                <a:ea typeface="游ゴシック"/>
+                <a:cs typeface="游ゴシック"/>
+              </a:rPr>
+              <a:t>発表リハーサル</a:t>
+            </a:r>
+          </a:p>
+        </p:txBody>
+      </p:sp>
+      <p:sp>
+        <p:nvSpPr>
+          <p:cNvPr id="32" name="Rounded Rectangle 31"/>
+          <p:cNvSpPr/>
+          <p:nvPr/>
+        </p:nvSpPr>
+        <p:spPr>
+          <a:xfrm>
+            <a:off x="9852733" y="2440000"/>
+            <a:ext cx="2772729" cy="3760000"/>
+          </a:xfrm>
+          <a:prstGeom prst="roundRect">
+            <a:avLst>
+              <a:gd name="adj" fmla="val 5000"/>
             </a:avLst>
           </a:prstGeom>
           <a:solidFill>
@@ -5455,7 +6108,7 @@
           <a:effectLst>
             <a:outerShdw blurRad="50800" dist="25400" dir="5400000" rotWithShape="0">
               <a:srgbClr val="8AA6B0">
-                <a:alpha val="38000"/>
+                <a:alpha val="36000"/>
               </a:srgbClr>
             </a:outerShdw>
           </a:effectLst>
@@ -5484,14 +6137,14 @@
       </p:sp>
       <p:sp>
         <p:nvSpPr>
-          <p:cNvPr id="20" name="Oval 19"/>
+          <p:cNvPr id="33" name="Oval 32"/>
           <p:cNvSpPr/>
           <p:nvPr/>
         </p:nvSpPr>
         <p:spPr>
           <a:xfrm>
-            <a:off x="1044546" y="4270000"/>
-            <a:ext cx="440000" cy="440000"/>
+            <a:off x="10082733" y="2670000"/>
+            <a:ext cx="470000" cy="470000"/>
           </a:xfrm>
           <a:prstGeom prst="ellipse">
             <a:avLst/>
@@ -5532,21 +6185,21 @@
                 <a:ea typeface="游ゴシック"/>
                 <a:cs typeface="游ゴシック"/>
               </a:rPr>
-              <a:t>1</a:t>
-            </a:r>
-          </a:p>
-        </p:txBody>
-      </p:sp>
-      <p:sp>
-        <p:nvSpPr>
-          <p:cNvPr id="21" name="TextBox 20"/>
+              <a:t>④</a:t>
+            </a:r>
+          </a:p>
+        </p:txBody>
+      </p:sp>
+      <p:sp>
+        <p:nvSpPr>
+          <p:cNvPr id="34" name="TextBox 33"/>
           <p:cNvSpPr txBox="1"/>
           <p:nvPr/>
         </p:nvSpPr>
         <p:spPr>
           <a:xfrm>
-            <a:off x="1044546" y="4830000"/>
-            <a:ext cx="3316972" cy="620000"/>
+            <a:off x="10642733" y="2670000"/>
+            <a:ext cx="1922729" cy="500000"/>
           </a:xfrm>
           <a:prstGeom prst="rect">
             <a:avLst/>
@@ -5554,21 +6207,21 @@
           <a:noFill/>
         </p:spPr>
         <p:txBody>
-          <a:bodyPr wrap="square" anchor="t" lIns="0" rIns="0" tIns="0" bIns="0">
+          <a:bodyPr wrap="square" anchor="ctr" lIns="0" rIns="0" tIns="0" bIns="0">
             <a:spAutoFit/>
           </a:bodyPr>
           <a:lstStyle/>
           <a:p>
             <a:pPr algn="l">
               <a:lnSpc>
-                <a:spcPct val="110000"/>
+                <a:spcPct val="100000"/>
               </a:lnSpc>
               <a:spcAft>
                 <a:spcPts val="0"/>
               </a:spcAft>
             </a:pPr>
             <a:r>
-              <a:rPr sz="1450" b="1">
+              <a:rPr sz="2300" b="1">
                 <a:solidFill>
                   <a:srgbClr val="EC856F"/>
                 </a:solidFill>
@@ -5576,21 +6229,21 @@
                 <a:ea typeface="游ゴシック"/>
                 <a:cs typeface="游ゴシック"/>
               </a:rPr>
-              <a:t>M365内で構成する</a:t>
-            </a:r>
-          </a:p>
-        </p:txBody>
-      </p:sp>
-      <p:sp>
-        <p:nvSpPr>
-          <p:cNvPr id="22" name="TextBox 21"/>
+              <a:t>10月</a:t>
+            </a:r>
+          </a:p>
+        </p:txBody>
+      </p:sp>
+      <p:sp>
+        <p:nvSpPr>
+          <p:cNvPr id="35" name="TextBox 34"/>
           <p:cNvSpPr txBox="1"/>
           <p:nvPr/>
         </p:nvSpPr>
         <p:spPr>
           <a:xfrm>
-            <a:off x="1044546" y="5360000"/>
-            <a:ext cx="3316972" cy="930000"/>
+            <a:off x="10082733" y="3260000"/>
+            <a:ext cx="2312729" cy="380000"/>
           </a:xfrm>
           <a:prstGeom prst="rect">
             <a:avLst/>
@@ -5605,94 +6258,160 @@
           <a:p>
             <a:pPr algn="l">
               <a:lnSpc>
-                <a:spcPct val="122000"/>
+                <a:spcPct val="100000"/>
               </a:lnSpc>
               <a:spcAft>
                 <a:spcPts val="0"/>
               </a:spcAft>
             </a:pPr>
             <a:r>
+              <a:rPr sz="1300" b="1">
+                <a:solidFill>
+                  <a:srgbClr val="EC856F"/>
+                </a:solidFill>
+                <a:latin typeface="游ゴシック"/>
+                <a:ea typeface="游ゴシック"/>
+                <a:cs typeface="游ゴシック"/>
+              </a:rPr>
+              <a:t>成果報告</a:t>
+            </a:r>
+          </a:p>
+        </p:txBody>
+      </p:sp>
+      <p:sp>
+        <p:nvSpPr>
+          <p:cNvPr id="36" name="TextBox 35"/>
+          <p:cNvSpPr txBox="1"/>
+          <p:nvPr/>
+        </p:nvSpPr>
+        <p:spPr>
+          <a:xfrm>
+            <a:off x="10082733" y="3760000"/>
+            <a:ext cx="2312729" cy="2260000"/>
+          </a:xfrm>
+          <a:prstGeom prst="rect">
+            <a:avLst/>
+          </a:prstGeom>
+          <a:noFill/>
+        </p:spPr>
+        <p:txBody>
+          <a:bodyPr wrap="square" anchor="t" lIns="0" rIns="0" tIns="0" bIns="0">
+            <a:spAutoFit/>
+          </a:bodyPr>
+          <a:lstStyle/>
+          <a:p>
+            <a:pPr algn="l">
+              <a:lnSpc>
+                <a:spcPct val="114000"/>
+              </a:lnSpc>
+              <a:spcAft>
+                <a:spcPts val="1200"/>
+              </a:spcAft>
+            </a:pPr>
+            <a:r>
               <a:rPr sz="1200" b="0">
                 <a:solidFill>
+                  <a:srgbClr val="EC856F"/>
+                </a:solidFill>
+                <a:latin typeface="游ゴシック"/>
+                <a:ea typeface="游ゴシック"/>
+                <a:cs typeface="游ゴシック"/>
+              </a:rPr>
+              <a:t>・</a:t>
+            </a:r>
+            <a:r>
+              <a:rPr sz="1250" b="0">
+                <a:solidFill>
                   <a:srgbClr val="232323"/>
                 </a:solidFill>
                 <a:latin typeface="游ゴシック"/>
                 <a:ea typeface="游ゴシック"/>
                 <a:cs typeface="游ゴシック"/>
               </a:rPr>
-              <a:t>外部システム（Salesforce など）への接続はNGとさせてください。</a:t>
-            </a:r>
-          </a:p>
-        </p:txBody>
-      </p:sp>
-      <p:sp>
-        <p:nvSpPr>
-          <p:cNvPr id="23" name="Rounded Rectangle 22"/>
+              <a:t>社長・役員向け成果報告</a:t>
+            </a:r>
+          </a:p>
+          <a:p>
+            <a:pPr algn="l">
+              <a:lnSpc>
+                <a:spcPct val="114000"/>
+              </a:lnSpc>
+              <a:spcAft>
+                <a:spcPts val="1200"/>
+              </a:spcAft>
+            </a:pPr>
+            <a:r>
+              <a:rPr sz="1200" b="0">
+                <a:solidFill>
+                  <a:srgbClr val="EC856F"/>
+                </a:solidFill>
+                <a:latin typeface="游ゴシック"/>
+                <a:ea typeface="游ゴシック"/>
+                <a:cs typeface="游ゴシック"/>
+              </a:rPr>
+              <a:t>・</a:t>
+            </a:r>
+            <a:r>
+              <a:rPr sz="1250" b="0">
+                <a:solidFill>
+                  <a:srgbClr val="232323"/>
+                </a:solidFill>
+                <a:latin typeface="游ゴシック"/>
+                <a:ea typeface="游ゴシック"/>
+                <a:cs typeface="游ゴシック"/>
+              </a:rPr>
+              <a:t>全11チームが発表</a:t>
+            </a:r>
+          </a:p>
+          <a:p>
+            <a:pPr algn="l">
+              <a:lnSpc>
+                <a:spcPct val="114000"/>
+              </a:lnSpc>
+              <a:spcAft>
+                <a:spcPts val="1200"/>
+              </a:spcAft>
+            </a:pPr>
+            <a:r>
+              <a:rPr sz="1200" b="0">
+                <a:solidFill>
+                  <a:srgbClr val="EC856F"/>
+                </a:solidFill>
+                <a:latin typeface="游ゴシック"/>
+                <a:ea typeface="游ゴシック"/>
+                <a:cs typeface="游ゴシック"/>
+              </a:rPr>
+              <a:t>・</a:t>
+            </a:r>
+            <a:r>
+              <a:rPr sz="1250" b="0">
+                <a:solidFill>
+                  <a:srgbClr val="232323"/>
+                </a:solidFill>
+                <a:latin typeface="游ゴシック"/>
+                <a:ea typeface="游ゴシック"/>
+                <a:cs typeface="游ゴシック"/>
+              </a:rPr>
+              <a:t>1チーム 10分</a:t>
+            </a:r>
+          </a:p>
+        </p:txBody>
+      </p:sp>
+      <p:sp>
+        <p:nvSpPr>
+          <p:cNvPr id="37" name="Rounded Rectangle 36"/>
           <p:cNvSpPr/>
           <p:nvPr/>
         </p:nvSpPr>
         <p:spPr>
           <a:xfrm>
-            <a:off x="4831518" y="4030000"/>
-            <a:ext cx="3776972" cy="2360000"/>
+            <a:off x="3827275" y="6330000"/>
+            <a:ext cx="5785458" cy="460000"/>
           </a:xfrm>
           <a:prstGeom prst="roundRect">
             <a:avLst>
-              <a:gd name="adj" fmla="val 6000"/>
+              <a:gd name="adj" fmla="val 50000"/>
             </a:avLst>
-          </a:prstGeom>
-          <a:solidFill>
-            <a:srgbClr val="FCEEE9"/>
-          </a:solidFill>
-          <a:ln w="9525">
-            <a:solidFill>
-              <a:srgbClr val="F0B7A8"/>
-            </a:solidFill>
-          </a:ln>
-          <a:effectLst/>
-          <a:effectLst>
-            <a:outerShdw blurRad="50800" dist="25400" dir="5400000" rotWithShape="0">
-              <a:srgbClr val="8AA6B0">
-                <a:alpha val="38000"/>
-              </a:srgbClr>
-            </a:outerShdw>
-          </a:effectLst>
-        </p:spPr>
-        <p:style>
-          <a:lnRef idx="1">
-            <a:schemeClr val="accent1"/>
-          </a:lnRef>
-          <a:fillRef idx="3">
-            <a:schemeClr val="accent1"/>
-          </a:fillRef>
-          <a:effectRef idx="2">
-            <a:schemeClr val="accent1"/>
-          </a:effectRef>
-          <a:fontRef idx="minor">
-            <a:schemeClr val="lt1"/>
-          </a:fontRef>
-        </p:style>
-        <p:txBody>
-          <a:bodyPr rtlCol="0" anchor="ctr" wrap="square"/>
-          <a:lstStyle/>
-          <a:p>
-            <a:pPr algn="ctr"/>
-          </a:p>
-        </p:txBody>
-      </p:sp>
-      <p:sp>
-        <p:nvSpPr>
-          <p:cNvPr id="24" name="Oval 23"/>
-          <p:cNvSpPr/>
-          <p:nvPr/>
-        </p:nvSpPr>
-        <p:spPr>
-          <a:xfrm>
-            <a:off x="5061518" y="4270000"/>
-            <a:ext cx="440000" cy="440000"/>
-          </a:xfrm>
-          <a:prstGeom prst="ellipse">
-            <a:avLst/>
           </a:prstGeom>
           <a:solidFill>
             <a:srgbClr val="EC856F"/>
@@ -5701,6 +6420,13 @@
             <a:noFill/>
           </a:ln>
           <a:effectLst/>
+          <a:effectLst>
+            <a:outerShdw blurRad="50800" dist="25400" dir="5400000" rotWithShape="0">
+              <a:srgbClr val="8AA6B0">
+                <a:alpha val="36000"/>
+              </a:srgbClr>
+            </a:outerShdw>
+          </a:effectLst>
         </p:spPr>
         <p:style>
           <a:lnRef idx="1">
@@ -5717,210 +6443,19 @@
           </a:fontRef>
         </p:style>
         <p:txBody>
-          <a:bodyPr rtlCol="0" anchor="ctr" lIns="0" rIns="0" tIns="0" bIns="0" wrap="none"/>
-          <a:lstStyle/>
-          <a:p>
-            <a:pPr algn="ctr"/>
-            <a:r>
-              <a:rPr sz="1700" b="1">
-                <a:solidFill>
-                  <a:srgbClr val="FFFFFF"/>
-                </a:solidFill>
-                <a:latin typeface="游ゴシック"/>
-                <a:ea typeface="游ゴシック"/>
-                <a:cs typeface="游ゴシック"/>
-              </a:rPr>
-              <a:t>2</a:t>
-            </a:r>
-          </a:p>
-        </p:txBody>
-      </p:sp>
-      <p:sp>
-        <p:nvSpPr>
-          <p:cNvPr id="25" name="TextBox 24"/>
-          <p:cNvSpPr txBox="1"/>
-          <p:nvPr/>
-        </p:nvSpPr>
-        <p:spPr>
-          <a:xfrm>
-            <a:off x="5061518" y="4830000"/>
-            <a:ext cx="3316972" cy="620000"/>
-          </a:xfrm>
-          <a:prstGeom prst="rect">
-            <a:avLst/>
-          </a:prstGeom>
-          <a:noFill/>
-        </p:spPr>
-        <p:txBody>
-          <a:bodyPr wrap="square" anchor="t" lIns="0" rIns="0" tIns="0" bIns="0">
-            <a:spAutoFit/>
-          </a:bodyPr>
-          <a:lstStyle/>
-          <a:p>
-            <a:pPr algn="l">
+          <a:bodyPr rtlCol="0" anchor="ctr" wrap="square" lIns="0" rIns="0" tIns="0" bIns="0"/>
+          <a:lstStyle/>
+          <a:p>
+            <a:pPr algn="ctr">
               <a:lnSpc>
-                <a:spcPct val="110000"/>
+                <a:spcPct val="100000"/>
               </a:lnSpc>
               <a:spcAft>
                 <a:spcPts val="0"/>
               </a:spcAft>
             </a:pPr>
             <a:r>
-              <a:rPr sz="1450" b="1">
-                <a:solidFill>
-                  <a:srgbClr val="EC856F"/>
-                </a:solidFill>
-                <a:latin typeface="游ゴシック"/>
-                <a:ea typeface="游ゴシック"/>
-                <a:cs typeface="游ゴシック"/>
-              </a:rPr>
-              <a:t>個人情報・極秘情報を含めない</a:t>
-            </a:r>
-          </a:p>
-        </p:txBody>
-      </p:sp>
-      <p:sp>
-        <p:nvSpPr>
-          <p:cNvPr id="26" name="TextBox 25"/>
-          <p:cNvSpPr txBox="1"/>
-          <p:nvPr/>
-        </p:nvSpPr>
-        <p:spPr>
-          <a:xfrm>
-            <a:off x="5061518" y="5360000"/>
-            <a:ext cx="3316972" cy="930000"/>
-          </a:xfrm>
-          <a:prstGeom prst="rect">
-            <a:avLst/>
-          </a:prstGeom>
-          <a:noFill/>
-        </p:spPr>
-        <p:txBody>
-          <a:bodyPr wrap="square" anchor="t" lIns="0" rIns="0" tIns="0" bIns="0">
-            <a:spAutoFit/>
-          </a:bodyPr>
-          <a:lstStyle/>
-          <a:p>
-            <a:pPr algn="l">
-              <a:lnSpc>
-                <a:spcPct val="122000"/>
-              </a:lnSpc>
-              <a:spcAft>
-                <a:spcPts val="0"/>
-              </a:spcAft>
-            </a:pPr>
-            <a:r>
-              <a:rPr sz="1200" b="0">
-                <a:solidFill>
-                  <a:srgbClr val="232323"/>
-                </a:solidFill>
-                <a:latin typeface="游ゴシック"/>
-                <a:ea typeface="游ゴシック"/>
-                <a:cs typeface="游ゴシック"/>
-              </a:rPr>
-              <a:t>アプリで読み込む対象に、個人情報や極秘情報が含まれないようにしてください。</a:t>
-            </a:r>
-          </a:p>
-        </p:txBody>
-      </p:sp>
-      <p:sp>
-        <p:nvSpPr>
-          <p:cNvPr id="27" name="Rounded Rectangle 26"/>
-          <p:cNvSpPr/>
-          <p:nvPr/>
-        </p:nvSpPr>
-        <p:spPr>
-          <a:xfrm>
-            <a:off x="8848490" y="4030000"/>
-            <a:ext cx="3776972" cy="2360000"/>
-          </a:xfrm>
-          <a:prstGeom prst="roundRect">
-            <a:avLst>
-              <a:gd name="adj" fmla="val 6000"/>
-            </a:avLst>
-          </a:prstGeom>
-          <a:solidFill>
-            <a:srgbClr val="FCEEE9"/>
-          </a:solidFill>
-          <a:ln w="9525">
-            <a:solidFill>
-              <a:srgbClr val="F0B7A8"/>
-            </a:solidFill>
-          </a:ln>
-          <a:effectLst/>
-          <a:effectLst>
-            <a:outerShdw blurRad="50800" dist="25400" dir="5400000" rotWithShape="0">
-              <a:srgbClr val="8AA6B0">
-                <a:alpha val="38000"/>
-              </a:srgbClr>
-            </a:outerShdw>
-          </a:effectLst>
-        </p:spPr>
-        <p:style>
-          <a:lnRef idx="1">
-            <a:schemeClr val="accent1"/>
-          </a:lnRef>
-          <a:fillRef idx="3">
-            <a:schemeClr val="accent1"/>
-          </a:fillRef>
-          <a:effectRef idx="2">
-            <a:schemeClr val="accent1"/>
-          </a:effectRef>
-          <a:fontRef idx="minor">
-            <a:schemeClr val="lt1"/>
-          </a:fontRef>
-        </p:style>
-        <p:txBody>
-          <a:bodyPr rtlCol="0" anchor="ctr" wrap="square"/>
-          <a:lstStyle/>
-          <a:p>
-            <a:pPr algn="ctr"/>
-          </a:p>
-        </p:txBody>
-      </p:sp>
-      <p:sp>
-        <p:nvSpPr>
-          <p:cNvPr id="28" name="Oval 27"/>
-          <p:cNvSpPr/>
-          <p:nvPr/>
-        </p:nvSpPr>
-        <p:spPr>
-          <a:xfrm>
-            <a:off x="9078490" y="4270000"/>
-            <a:ext cx="440000" cy="440000"/>
-          </a:xfrm>
-          <a:prstGeom prst="ellipse">
-            <a:avLst/>
-          </a:prstGeom>
-          <a:solidFill>
-            <a:srgbClr val="EC856F"/>
-          </a:solidFill>
-          <a:ln>
-            <a:noFill/>
-          </a:ln>
-          <a:effectLst/>
-        </p:spPr>
-        <p:style>
-          <a:lnRef idx="1">
-            <a:schemeClr val="accent1"/>
-          </a:lnRef>
-          <a:fillRef idx="3">
-            <a:schemeClr val="accent1"/>
-          </a:fillRef>
-          <a:effectRef idx="2">
-            <a:schemeClr val="accent1"/>
-          </a:effectRef>
-          <a:fontRef idx="minor">
-            <a:schemeClr val="lt1"/>
-          </a:fontRef>
-        </p:style>
-        <p:txBody>
-          <a:bodyPr rtlCol="0" anchor="ctr" lIns="0" rIns="0" tIns="0" bIns="0" wrap="none"/>
-          <a:lstStyle/>
-          <a:p>
-            <a:pPr algn="ctr"/>
-            <a:r>
-              <a:rPr sz="1700" b="1">
+              <a:rPr sz="1300" b="1">
                 <a:solidFill>
                   <a:srgbClr val="FFFFFF"/>
                 </a:solidFill>
@@ -5928,95 +6463,7 @@
                 <a:ea typeface="游ゴシック"/>
                 <a:cs typeface="游ゴシック"/>
               </a:rPr>
-              <a:t>3</a:t>
-            </a:r>
-          </a:p>
-        </p:txBody>
-      </p:sp>
-      <p:sp>
-        <p:nvSpPr>
-          <p:cNvPr id="29" name="TextBox 28"/>
-          <p:cNvSpPr txBox="1"/>
-          <p:nvPr/>
-        </p:nvSpPr>
-        <p:spPr>
-          <a:xfrm>
-            <a:off x="9078490" y="4830000"/>
-            <a:ext cx="3316972" cy="620000"/>
-          </a:xfrm>
-          <a:prstGeom prst="rect">
-            <a:avLst/>
-          </a:prstGeom>
-          <a:noFill/>
-        </p:spPr>
-        <p:txBody>
-          <a:bodyPr wrap="square" anchor="t" lIns="0" rIns="0" tIns="0" bIns="0">
-            <a:spAutoFit/>
-          </a:bodyPr>
-          <a:lstStyle/>
-          <a:p>
-            <a:pPr algn="l">
-              <a:lnSpc>
-                <a:spcPct val="110000"/>
-              </a:lnSpc>
-              <a:spcAft>
-                <a:spcPts val="0"/>
-              </a:spcAft>
-            </a:pPr>
-            <a:r>
-              <a:rPr sz="1450" b="1">
-                <a:solidFill>
-                  <a:srgbClr val="EC856F"/>
-                </a:solidFill>
-                <a:latin typeface="游ゴシック"/>
-                <a:ea typeface="游ゴシック"/>
-                <a:cs typeface="游ゴシック"/>
-              </a:rPr>
-              <a:t>外部サイトへの情報収集はNG</a:t>
-            </a:r>
-          </a:p>
-        </p:txBody>
-      </p:sp>
-      <p:sp>
-        <p:nvSpPr>
-          <p:cNvPr id="30" name="TextBox 29"/>
-          <p:cNvSpPr txBox="1"/>
-          <p:nvPr/>
-        </p:nvSpPr>
-        <p:spPr>
-          <a:xfrm>
-            <a:off x="9078490" y="5360000"/>
-            <a:ext cx="3316972" cy="930000"/>
-          </a:xfrm>
-          <a:prstGeom prst="rect">
-            <a:avLst/>
-          </a:prstGeom>
-          <a:noFill/>
-        </p:spPr>
-        <p:txBody>
-          <a:bodyPr wrap="square" anchor="t" lIns="0" rIns="0" tIns="0" bIns="0">
-            <a:spAutoFit/>
-          </a:bodyPr>
-          <a:lstStyle/>
-          <a:p>
-            <a:pPr algn="l">
-              <a:lnSpc>
-                <a:spcPct val="122000"/>
-              </a:lnSpc>
-              <a:spcAft>
-                <a:spcPts val="0"/>
-              </a:spcAft>
-            </a:pPr>
-            <a:r>
-              <a:rPr sz="1200" b="0">
-                <a:solidFill>
-                  <a:srgbClr val="232323"/>
-                </a:solidFill>
-                <a:latin typeface="游ゴシック"/>
-                <a:ea typeface="游ゴシック"/>
-                <a:cs typeface="游ゴシック"/>
-              </a:rPr>
-              <a:t>スクレイピングに当たるため原則禁止です。（例：特定企業のIR情報などを収集し資料化）</a:t>
+              <a:t>メンター支援：週次・隔週の定例会（8〜9月）</a:t>
             </a:r>
           </a:p>
         </p:txBody>

</xml_diff>